<commit_message>
Fix Signal Color clear space
</commit_message>
<xml_diff>
--- a/brand/SHAYA-Signal-Color-Brand-Guidelines.pptx
+++ b/brand/SHAYA-Signal-Color-Brand-Guidelines.pptx
@@ -2,21 +2,21 @@
 <file path=ppt/presentation.xml><?xml version="1.0" encoding="utf-8"?>
 <p:presentation xmlns:p="http://schemas.openxmlformats.org/presentationml/2006/main">
   <p:sldMasterIdLst>
-    <p:sldMasterId xmlns:r="http://schemas.openxmlformats.org/officeDocument/2006/relationships" id="2147483648" r:id="Rf3e91b3e3d7a4991"/>
+    <p:sldMasterId xmlns:r="http://schemas.openxmlformats.org/officeDocument/2006/relationships" id="2147483648" r:id="R419a5c1f6c314c11"/>
   </p:sldMasterIdLst>
   <p:notesMasterIdLst>
-    <p:notesMasterId xmlns:r="http://schemas.openxmlformats.org/officeDocument/2006/relationships" r:id="Ra090802c49cf4815"/>
+    <p:notesMasterId xmlns:r="http://schemas.openxmlformats.org/officeDocument/2006/relationships" r:id="Rba868870b502452f"/>
   </p:notesMasterIdLst>
   <p:sldIdLst>
-    <p:sldId xmlns:r="http://schemas.openxmlformats.org/officeDocument/2006/relationships" id="256" r:id="Rc5626075e7564c44"/>
-    <p:sldId xmlns:r="http://schemas.openxmlformats.org/officeDocument/2006/relationships" id="257" r:id="Rc9317099b75443bc"/>
-    <p:sldId xmlns:r="http://schemas.openxmlformats.org/officeDocument/2006/relationships" id="258" r:id="Ra5480e8e65644068"/>
-    <p:sldId xmlns:r="http://schemas.openxmlformats.org/officeDocument/2006/relationships" id="259" r:id="Rf99916f830b54880"/>
-    <p:sldId xmlns:r="http://schemas.openxmlformats.org/officeDocument/2006/relationships" id="260" r:id="Rd1af9631e0fd4498"/>
-    <p:sldId xmlns:r="http://schemas.openxmlformats.org/officeDocument/2006/relationships" id="261" r:id="R49b614387b6d4a71"/>
-    <p:sldId xmlns:r="http://schemas.openxmlformats.org/officeDocument/2006/relationships" id="262" r:id="Rca941673486f4058"/>
-    <p:sldId xmlns:r="http://schemas.openxmlformats.org/officeDocument/2006/relationships" id="263" r:id="Re57613a0ccc140b4"/>
-    <p:sldId xmlns:r="http://schemas.openxmlformats.org/officeDocument/2006/relationships" id="264" r:id="Rcebb4eb943cf402f"/>
+    <p:sldId xmlns:r="http://schemas.openxmlformats.org/officeDocument/2006/relationships" id="256" r:id="R7e5b71feffe644e9"/>
+    <p:sldId xmlns:r="http://schemas.openxmlformats.org/officeDocument/2006/relationships" id="257" r:id="Rded9683338a0405c"/>
+    <p:sldId xmlns:r="http://schemas.openxmlformats.org/officeDocument/2006/relationships" id="258" r:id="R448cedb4e82646dd"/>
+    <p:sldId xmlns:r="http://schemas.openxmlformats.org/officeDocument/2006/relationships" id="259" r:id="R33b861ebaaea4eb4"/>
+    <p:sldId xmlns:r="http://schemas.openxmlformats.org/officeDocument/2006/relationships" id="260" r:id="Red461ac5911044cd"/>
+    <p:sldId xmlns:r="http://schemas.openxmlformats.org/officeDocument/2006/relationships" id="261" r:id="R9a2c3a268e4f42d7"/>
+    <p:sldId xmlns:r="http://schemas.openxmlformats.org/officeDocument/2006/relationships" id="262" r:id="R9da6708d13ff4c12"/>
+    <p:sldId xmlns:r="http://schemas.openxmlformats.org/officeDocument/2006/relationships" id="263" r:id="Rd7057f07774f4587"/>
+    <p:sldId xmlns:r="http://schemas.openxmlformats.org/officeDocument/2006/relationships" id="264" r:id="R324a7738623347f5"/>
   </p:sldIdLst>
   <p:sldSz cx="12192000" cy="6858000"/>
   <p:notesSz cx="6858000" cy="9144000"/>
@@ -1042,7 +1042,7 @@
   </p:cSld>
   <p:clrMap bg1="lt1" tx1="dk1" bg2="lt2" tx2="dk2" accent1="accent1" accent2="accent2" accent3="accent3" accent4="accent4" accent5="accent5" accent6="accent6" hlink="hlink" folHlink="folHlink"/>
   <p:sldLayoutIdLst>
-    <p:sldLayoutId xmlns:r="http://schemas.openxmlformats.org/officeDocument/2006/relationships" id="2147483649" r:id="R84118aaf9df24c82"/>
+    <p:sldLayoutId xmlns:r="http://schemas.openxmlformats.org/officeDocument/2006/relationships" id="2147483649" r:id="R3ec4251483274117"/>
   </p:sldLayoutIdLst>
   <p:txStyles>
     <p:titleStyle>
@@ -1597,7 +1597,7 @@
           <p:nvPr/>
         </p:nvPicPr>
         <p:blipFill>
-          <a:blip xmlns:r="http://schemas.openxmlformats.org/officeDocument/2006/relationships" xmlns:a="http://schemas.openxmlformats.org/drawingml/2006/main" r:embed="Rd9b50c99e4164cfe"/>
+          <a:blip xmlns:r="http://schemas.openxmlformats.org/officeDocument/2006/relationships" xmlns:a="http://schemas.openxmlformats.org/drawingml/2006/main" r:embed="R517f607e53da48b3"/>
           <a:stretch xmlns:a="http://schemas.openxmlformats.org/drawingml/2006/main"/>
         </p:blipFill>
         <p:spPr>
@@ -1615,7 +1615,7 @@
           <p:cNvPr id="2" name="cover-band">
             <a:extLst xmlns:a="http://schemas.openxmlformats.org/drawingml/2006/main">
               <a:ext uri="{FF2B5EF4-FFF2-40B4-BE49-F238E27FC236}">
-                <a16:creationId xmlns:a16="http://schemas.microsoft.com/office/drawing/2014/main" id="{47F02D4D-9DDD-4355-B18F-F104001739D0}"/>
+                <a16:creationId xmlns:a16="http://schemas.microsoft.com/office/drawing/2014/main" id="{1EF4143F-71AB-403D-9D98-309904731002}"/>
               </a:ext>
             </a:extLst>
           </p:cNvPr>
@@ -1646,7 +1646,7 @@
           <p:cNvPr id="3" name="cover-title">
             <a:extLst xmlns:a="http://schemas.openxmlformats.org/drawingml/2006/main">
               <a:ext uri="{FF2B5EF4-FFF2-40B4-BE49-F238E27FC236}">
-                <a16:creationId xmlns:a16="http://schemas.microsoft.com/office/drawing/2014/main" id="{1BC2E4BF-4787-4174-9B14-A47975B67560}"/>
+                <a16:creationId xmlns:a16="http://schemas.microsoft.com/office/drawing/2014/main" id="{546248F6-A2DD-4766-81B2-83CF953F4A85}"/>
               </a:ext>
             </a:extLst>
           </p:cNvPr>
@@ -1696,7 +1696,7 @@
           <p:cNvPr id="4" name="cover-version">
             <a:extLst xmlns:a="http://schemas.openxmlformats.org/drawingml/2006/main">
               <a:ext uri="{FF2B5EF4-FFF2-40B4-BE49-F238E27FC236}">
-                <a16:creationId xmlns:a16="http://schemas.microsoft.com/office/drawing/2014/main" id="{CF5F4CA8-8566-451C-906F-B55A81D7346C}"/>
+                <a16:creationId xmlns:a16="http://schemas.microsoft.com/office/drawing/2014/main" id="{3F2CAA26-9887-4DBF-85E7-48F0A7B370EE}"/>
               </a:ext>
             </a:extLst>
           </p:cNvPr>
@@ -1746,7 +1746,7 @@
           <p:cNvPr id="5" name="cover-color-1">
             <a:extLst xmlns:a="http://schemas.openxmlformats.org/drawingml/2006/main">
               <a:ext uri="{FF2B5EF4-FFF2-40B4-BE49-F238E27FC236}">
-                <a16:creationId xmlns:a16="http://schemas.microsoft.com/office/drawing/2014/main" id="{47330158-4132-4A66-A01A-A57425352845}"/>
+                <a16:creationId xmlns:a16="http://schemas.microsoft.com/office/drawing/2014/main" id="{86590DDD-F991-4193-85E8-20C309E9CCC0}"/>
               </a:ext>
             </a:extLst>
           </p:cNvPr>
@@ -1777,7 +1777,7 @@
           <p:cNvPr id="6" name="cover-color-2">
             <a:extLst xmlns:a="http://schemas.openxmlformats.org/drawingml/2006/main">
               <a:ext uri="{FF2B5EF4-FFF2-40B4-BE49-F238E27FC236}">
-                <a16:creationId xmlns:a16="http://schemas.microsoft.com/office/drawing/2014/main" id="{8B2233E6-F5D6-4C65-9DCE-84ABEB214234}"/>
+                <a16:creationId xmlns:a16="http://schemas.microsoft.com/office/drawing/2014/main" id="{306B3CD5-3BF4-4B63-877A-2A5CDCFF63E8}"/>
               </a:ext>
             </a:extLst>
           </p:cNvPr>
@@ -1808,7 +1808,7 @@
           <p:cNvPr id="7" name="cover-color-3">
             <a:extLst xmlns:a="http://schemas.openxmlformats.org/drawingml/2006/main">
               <a:ext uri="{FF2B5EF4-FFF2-40B4-BE49-F238E27FC236}">
-                <a16:creationId xmlns:a16="http://schemas.microsoft.com/office/drawing/2014/main" id="{42AA4551-51AD-4D60-95D4-8D7A67B4CBEE}"/>
+                <a16:creationId xmlns:a16="http://schemas.microsoft.com/office/drawing/2014/main" id="{131D81A9-054E-4EB5-864C-855A33D623B6}"/>
               </a:ext>
             </a:extLst>
           </p:cNvPr>
@@ -1839,7 +1839,7 @@
           <p:cNvPr id="8" name="cover-color-4">
             <a:extLst xmlns:a="http://schemas.openxmlformats.org/drawingml/2006/main">
               <a:ext uri="{FF2B5EF4-FFF2-40B4-BE49-F238E27FC236}">
-                <a16:creationId xmlns:a16="http://schemas.microsoft.com/office/drawing/2014/main" id="{1A721A97-05C7-4301-AD17-F26777057E43}"/>
+                <a16:creationId xmlns:a16="http://schemas.microsoft.com/office/drawing/2014/main" id="{126832BC-2978-48DD-B5A5-CB68B4E999B2}"/>
               </a:ext>
             </a:extLst>
           </p:cNvPr>
@@ -1870,7 +1870,7 @@
           <p:cNvPr id="9" name="cover-color-5">
             <a:extLst xmlns:a="http://schemas.openxmlformats.org/drawingml/2006/main">
               <a:ext uri="{FF2B5EF4-FFF2-40B4-BE49-F238E27FC236}">
-                <a16:creationId xmlns:a16="http://schemas.microsoft.com/office/drawing/2014/main" id="{B2E1F459-661D-47D7-9094-0828D0AD76DC}"/>
+                <a16:creationId xmlns:a16="http://schemas.microsoft.com/office/drawing/2014/main" id="{40746B24-F67C-499D-8840-ECA1085CB38D}"/>
               </a:ext>
             </a:extLst>
           </p:cNvPr>
@@ -1899,7 +1899,7 @@
     </p:spTree>
     <p:extLst>
       <p:ext uri="{BB962C8B-B14F-4D97-AF65-F5344CB8AC3E}">
-        <p14:creationId xmlns:p14="http://schemas.microsoft.com/office/powerpoint/2010/main" val="1521166968"/>
+        <p14:creationId xmlns:p14="http://schemas.microsoft.com/office/powerpoint/2010/main" val="1393332678"/>
       </p:ext>
     </p:extLst>
   </p:cSld>
@@ -1930,7 +1930,7 @@
           <p:cNvPr id="18" name="eyebrow">
             <a:extLst xmlns:a="http://schemas.openxmlformats.org/drawingml/2006/main">
               <a:ext uri="{FF2B5EF4-FFF2-40B4-BE49-F238E27FC236}">
-                <a16:creationId xmlns:a16="http://schemas.microsoft.com/office/drawing/2014/main" id="{2EEBED5B-242A-4C13-B9EA-A30BE75B4780}"/>
+                <a16:creationId xmlns:a16="http://schemas.microsoft.com/office/drawing/2014/main" id="{69903C1E-DB75-4D58-B0CD-10E8380BBAC2}"/>
               </a:ext>
             </a:extLst>
           </p:cNvPr>
@@ -1980,7 +1980,7 @@
           <p:cNvPr id="2" name="slide-title">
             <a:extLst xmlns:a="http://schemas.openxmlformats.org/drawingml/2006/main">
               <a:ext uri="{FF2B5EF4-FFF2-40B4-BE49-F238E27FC236}">
-                <a16:creationId xmlns:a16="http://schemas.microsoft.com/office/drawing/2014/main" id="{D0BA2B1E-BDE7-4D3F-A489-410261949253}"/>
+                <a16:creationId xmlns:a16="http://schemas.microsoft.com/office/drawing/2014/main" id="{3066AA24-22C8-4B48-A812-D618D3E84027}"/>
               </a:ext>
             </a:extLst>
           </p:cNvPr>
@@ -2030,7 +2030,7 @@
           <p:cNvPr id="3" name="core-mark-field">
             <a:extLst xmlns:a="http://schemas.openxmlformats.org/drawingml/2006/main">
               <a:ext uri="{FF2B5EF4-FFF2-40B4-BE49-F238E27FC236}">
-                <a16:creationId xmlns:a16="http://schemas.microsoft.com/office/drawing/2014/main" id="{8D2F8B67-680F-4DFB-A132-20ACC45F0A49}"/>
+                <a16:creationId xmlns:a16="http://schemas.microsoft.com/office/drawing/2014/main" id="{B9BE2E55-5246-4E7B-A054-65779DAFB88B}"/>
               </a:ext>
             </a:extLst>
           </p:cNvPr>
@@ -2065,10 +2065,10 @@
           <p:nvPr/>
         </p:nvPicPr>
         <p:blipFill>
-          <a:blip xmlns:r="http://schemas.openxmlformats.org/officeDocument/2006/relationships" xmlns:a="http://schemas.openxmlformats.org/drawingml/2006/main" r:embed="R5788c16c49b641fd">
+          <a:blip xmlns:r="http://schemas.openxmlformats.org/officeDocument/2006/relationships" xmlns:a="http://schemas.openxmlformats.org/drawingml/2006/main" r:embed="R4d0c9564272b4930">
             <a:extLst>
               <a:ext uri="{96DAC541-7B7A-43D3-8B79-37D633B846F1}">
-                <asvg:svgBlip xmlns:asvg="http://schemas.microsoft.com/office/drawing/2016/SVG/main" r:embed="Rf7f5d4120a1149ed"/>
+                <asvg:svgBlip xmlns:asvg="http://schemas.microsoft.com/office/drawing/2016/SVG/main" r:embed="R9aa0e019358848f4"/>
               </a:ext>
             </a:extLst>
           </a:blip>
@@ -2089,7 +2089,7 @@
           <p:cNvPr id="5" name="core-tagline">
             <a:extLst xmlns:a="http://schemas.openxmlformats.org/drawingml/2006/main">
               <a:ext uri="{FF2B5EF4-FFF2-40B4-BE49-F238E27FC236}">
-                <a16:creationId xmlns:a16="http://schemas.microsoft.com/office/drawing/2014/main" id="{F394F2E7-E103-4B7C-B060-09DD65C61729}"/>
+                <a16:creationId xmlns:a16="http://schemas.microsoft.com/office/drawing/2014/main" id="{7256F35B-E20B-4DBF-A701-0FBF2164843E}"/>
               </a:ext>
             </a:extLst>
           </p:cNvPr>
@@ -2156,7 +2156,7 @@
           <p:cNvPr id="6" name="core-description">
             <a:extLst xmlns:a="http://schemas.openxmlformats.org/drawingml/2006/main">
               <a:ext uri="{FF2B5EF4-FFF2-40B4-BE49-F238E27FC236}">
-                <a16:creationId xmlns:a16="http://schemas.microsoft.com/office/drawing/2014/main" id="{090C26A9-D45A-4B11-87AD-A23F02356502}"/>
+                <a16:creationId xmlns:a16="http://schemas.microsoft.com/office/drawing/2014/main" id="{F099D328-7887-493D-84DC-3CEB75C01325}"/>
               </a:ext>
             </a:extLst>
           </p:cNvPr>
@@ -2206,7 +2206,7 @@
           <p:cNvPr id="7" name="trait-rule-1">
             <a:extLst xmlns:a="http://schemas.openxmlformats.org/drawingml/2006/main">
               <a:ext uri="{FF2B5EF4-FFF2-40B4-BE49-F238E27FC236}">
-                <a16:creationId xmlns:a16="http://schemas.microsoft.com/office/drawing/2014/main" id="{DA49EDCE-7777-4759-B058-5191392B1EC6}"/>
+                <a16:creationId xmlns:a16="http://schemas.microsoft.com/office/drawing/2014/main" id="{B0B4A446-0BAB-4A4B-95F4-158C7E43B351}"/>
               </a:ext>
             </a:extLst>
           </p:cNvPr>
@@ -2237,7 +2237,7 @@
           <p:cNvPr id="8" name="trait-title-1">
             <a:extLst xmlns:a="http://schemas.openxmlformats.org/drawingml/2006/main">
               <a:ext uri="{FF2B5EF4-FFF2-40B4-BE49-F238E27FC236}">
-                <a16:creationId xmlns:a16="http://schemas.microsoft.com/office/drawing/2014/main" id="{99CB0426-8EB7-400A-BB9E-2C0BC1BF95B2}"/>
+                <a16:creationId xmlns:a16="http://schemas.microsoft.com/office/drawing/2014/main" id="{EF187091-D218-4BA2-8452-C5EFAAA7DC7C}"/>
               </a:ext>
             </a:extLst>
           </p:cNvPr>
@@ -2287,7 +2287,7 @@
           <p:cNvPr id="9" name="trait-copy-1">
             <a:extLst xmlns:a="http://schemas.openxmlformats.org/drawingml/2006/main">
               <a:ext uri="{FF2B5EF4-FFF2-40B4-BE49-F238E27FC236}">
-                <a16:creationId xmlns:a16="http://schemas.microsoft.com/office/drawing/2014/main" id="{3F98D999-37F2-48F4-8674-66E56CB51749}"/>
+                <a16:creationId xmlns:a16="http://schemas.microsoft.com/office/drawing/2014/main" id="{A5B772D9-07B6-4780-BB38-BA7675C52436}"/>
               </a:ext>
             </a:extLst>
           </p:cNvPr>
@@ -2337,7 +2337,7 @@
           <p:cNvPr id="10" name="trait-rule-2">
             <a:extLst xmlns:a="http://schemas.openxmlformats.org/drawingml/2006/main">
               <a:ext uri="{FF2B5EF4-FFF2-40B4-BE49-F238E27FC236}">
-                <a16:creationId xmlns:a16="http://schemas.microsoft.com/office/drawing/2014/main" id="{36F99454-7126-4780-9631-37637D7C7973}"/>
+                <a16:creationId xmlns:a16="http://schemas.microsoft.com/office/drawing/2014/main" id="{AC825D8C-0CC7-461E-8AAD-DBA48A19C438}"/>
               </a:ext>
             </a:extLst>
           </p:cNvPr>
@@ -2368,7 +2368,7 @@
           <p:cNvPr id="11" name="trait-title-2">
             <a:extLst xmlns:a="http://schemas.openxmlformats.org/drawingml/2006/main">
               <a:ext uri="{FF2B5EF4-FFF2-40B4-BE49-F238E27FC236}">
-                <a16:creationId xmlns:a16="http://schemas.microsoft.com/office/drawing/2014/main" id="{18AFF734-B269-4A00-B8C9-C72A27CEE501}"/>
+                <a16:creationId xmlns:a16="http://schemas.microsoft.com/office/drawing/2014/main" id="{FF5E206C-E17E-406C-8566-15591C0ADB71}"/>
               </a:ext>
             </a:extLst>
           </p:cNvPr>
@@ -2418,7 +2418,7 @@
           <p:cNvPr id="12" name="trait-copy-2">
             <a:extLst xmlns:a="http://schemas.openxmlformats.org/drawingml/2006/main">
               <a:ext uri="{FF2B5EF4-FFF2-40B4-BE49-F238E27FC236}">
-                <a16:creationId xmlns:a16="http://schemas.microsoft.com/office/drawing/2014/main" id="{72344FC8-8CBB-44CA-A041-6B9333FFF0A4}"/>
+                <a16:creationId xmlns:a16="http://schemas.microsoft.com/office/drawing/2014/main" id="{1F20213C-2158-49F9-A520-E216DCA7CB30}"/>
               </a:ext>
             </a:extLst>
           </p:cNvPr>
@@ -2468,7 +2468,7 @@
           <p:cNvPr id="13" name="trait-rule-3">
             <a:extLst xmlns:a="http://schemas.openxmlformats.org/drawingml/2006/main">
               <a:ext uri="{FF2B5EF4-FFF2-40B4-BE49-F238E27FC236}">
-                <a16:creationId xmlns:a16="http://schemas.microsoft.com/office/drawing/2014/main" id="{DC2917DB-A41B-4763-8C3B-61547C597901}"/>
+                <a16:creationId xmlns:a16="http://schemas.microsoft.com/office/drawing/2014/main" id="{BCC58800-3876-4A66-A056-A02D3E330D8B}"/>
               </a:ext>
             </a:extLst>
           </p:cNvPr>
@@ -2499,7 +2499,7 @@
           <p:cNvPr id="14" name="trait-title-3">
             <a:extLst xmlns:a="http://schemas.openxmlformats.org/drawingml/2006/main">
               <a:ext uri="{FF2B5EF4-FFF2-40B4-BE49-F238E27FC236}">
-                <a16:creationId xmlns:a16="http://schemas.microsoft.com/office/drawing/2014/main" id="{6C104AF1-2BBD-4FB1-9B81-A50EBB9E2EAC}"/>
+                <a16:creationId xmlns:a16="http://schemas.microsoft.com/office/drawing/2014/main" id="{2D9DF844-A262-4F6F-817F-7FA8A9F1CA11}"/>
               </a:ext>
             </a:extLst>
           </p:cNvPr>
@@ -2549,7 +2549,7 @@
           <p:cNvPr id="15" name="trait-copy-3">
             <a:extLst xmlns:a="http://schemas.openxmlformats.org/drawingml/2006/main">
               <a:ext uri="{FF2B5EF4-FFF2-40B4-BE49-F238E27FC236}">
-                <a16:creationId xmlns:a16="http://schemas.microsoft.com/office/drawing/2014/main" id="{1C4F04A4-72C0-43D9-B503-B9A92E7A843F}"/>
+                <a16:creationId xmlns:a16="http://schemas.microsoft.com/office/drawing/2014/main" id="{546023D6-0218-4091-852E-8155D5E0AC96}"/>
               </a:ext>
             </a:extLst>
           </p:cNvPr>
@@ -2599,7 +2599,7 @@
           <p:cNvPr id="16" name="footer-brand">
             <a:extLst xmlns:a="http://schemas.openxmlformats.org/drawingml/2006/main">
               <a:ext uri="{FF2B5EF4-FFF2-40B4-BE49-F238E27FC236}">
-                <a16:creationId xmlns:a16="http://schemas.microsoft.com/office/drawing/2014/main" id="{0097ECFB-AF4A-4A22-B8A5-41A44C795DDA}"/>
+                <a16:creationId xmlns:a16="http://schemas.microsoft.com/office/drawing/2014/main" id="{BBAF6BBF-0CB1-4B0C-9D6D-2D1F2C923501}"/>
               </a:ext>
             </a:extLst>
           </p:cNvPr>
@@ -2649,7 +2649,7 @@
           <p:cNvPr id="17" name="footer-page">
             <a:extLst xmlns:a="http://schemas.openxmlformats.org/drawingml/2006/main">
               <a:ext uri="{FF2B5EF4-FFF2-40B4-BE49-F238E27FC236}">
-                <a16:creationId xmlns:a16="http://schemas.microsoft.com/office/drawing/2014/main" id="{B70B3466-46AD-4DAA-8EFD-DCCD664CDEA6}"/>
+                <a16:creationId xmlns:a16="http://schemas.microsoft.com/office/drawing/2014/main" id="{0A249BEA-500A-4463-AC17-5E2954632601}"/>
               </a:ext>
             </a:extLst>
           </p:cNvPr>
@@ -2697,7 +2697,7 @@
     </p:spTree>
     <p:extLst>
       <p:ext uri="{BB962C8B-B14F-4D97-AF65-F5344CB8AC3E}">
-        <p14:creationId xmlns:p14="http://schemas.microsoft.com/office/powerpoint/2010/main" val="354018287"/>
+        <p14:creationId xmlns:p14="http://schemas.microsoft.com/office/powerpoint/2010/main" val="1547273207"/>
       </p:ext>
     </p:extLst>
   </p:cSld>
@@ -2728,7 +2728,7 @@
           <p:cNvPr id="16" name="eyebrow">
             <a:extLst xmlns:a="http://schemas.openxmlformats.org/drawingml/2006/main">
               <a:ext uri="{FF2B5EF4-FFF2-40B4-BE49-F238E27FC236}">
-                <a16:creationId xmlns:a16="http://schemas.microsoft.com/office/drawing/2014/main" id="{761EB7E4-77FB-442C-B0EA-E2DEB5CC74FA}"/>
+                <a16:creationId xmlns:a16="http://schemas.microsoft.com/office/drawing/2014/main" id="{BC6A1737-E33A-4905-BEC9-EF1F3DE3A567}"/>
               </a:ext>
             </a:extLst>
           </p:cNvPr>
@@ -2778,7 +2778,7 @@
           <p:cNvPr id="2" name="slide-title">
             <a:extLst xmlns:a="http://schemas.openxmlformats.org/drawingml/2006/main">
               <a:ext uri="{FF2B5EF4-FFF2-40B4-BE49-F238E27FC236}">
-                <a16:creationId xmlns:a16="http://schemas.microsoft.com/office/drawing/2014/main" id="{B9B9807B-AB08-4515-BDC4-962CEBD9B4E0}"/>
+                <a16:creationId xmlns:a16="http://schemas.microsoft.com/office/drawing/2014/main" id="{652BBAD3-FF80-4140-AB05-7FB2020BEA84}"/>
               </a:ext>
             </a:extLst>
           </p:cNvPr>
@@ -2832,10 +2832,10 @@
           <p:nvPr/>
         </p:nvPicPr>
         <p:blipFill>
-          <a:blip xmlns:r="http://schemas.openxmlformats.org/officeDocument/2006/relationships" xmlns:a="http://schemas.openxmlformats.org/drawingml/2006/main" r:embed="R38123349dfaf4c51">
+          <a:blip xmlns:r="http://schemas.openxmlformats.org/officeDocument/2006/relationships" xmlns:a="http://schemas.openxmlformats.org/drawingml/2006/main" r:embed="Raa97e297e9184b57">
             <a:extLst>
               <a:ext uri="{96DAC541-7B7A-43D3-8B79-37D633B846F1}">
-                <asvg:svgBlip xmlns:asvg="http://schemas.microsoft.com/office/drawing/2016/SVG/main" r:embed="Rc218f3e98bbf44fb"/>
+                <asvg:svgBlip xmlns:asvg="http://schemas.microsoft.com/office/drawing/2016/SVG/main" r:embed="R2c0b87743ab74e94"/>
               </a:ext>
             </a:extLst>
           </a:blip>
@@ -2856,7 +2856,7 @@
           <p:cNvPr id="4" name="dark-mark-field">
             <a:extLst xmlns:a="http://schemas.openxmlformats.org/drawingml/2006/main">
               <a:ext uri="{FF2B5EF4-FFF2-40B4-BE49-F238E27FC236}">
-                <a16:creationId xmlns:a16="http://schemas.microsoft.com/office/drawing/2014/main" id="{29729BA5-1192-4C96-B07E-3C122AC404CF}"/>
+                <a16:creationId xmlns:a16="http://schemas.microsoft.com/office/drawing/2014/main" id="{68983A12-3609-4AF2-8FB0-AEEDB0A70D18}"/>
               </a:ext>
             </a:extLst>
           </p:cNvPr>
@@ -2891,10 +2891,10 @@
           <p:nvPr/>
         </p:nvPicPr>
         <p:blipFill>
-          <a:blip xmlns:r="http://schemas.openxmlformats.org/officeDocument/2006/relationships" xmlns:a="http://schemas.openxmlformats.org/drawingml/2006/main" r:embed="R54ecb9bb35434f2b">
+          <a:blip xmlns:r="http://schemas.openxmlformats.org/officeDocument/2006/relationships" xmlns:a="http://schemas.openxmlformats.org/drawingml/2006/main" r:embed="Rc74df3a5b71d42a9">
             <a:extLst>
               <a:ext uri="{96DAC541-7B7A-43D3-8B79-37D633B846F1}">
-                <asvg:svgBlip xmlns:asvg="http://schemas.microsoft.com/office/drawing/2016/SVG/main" r:embed="R1a0fc7257b49487e"/>
+                <asvg:svgBlip xmlns:asvg="http://schemas.microsoft.com/office/drawing/2016/SVG/main" r:embed="Rc80c5c236e904d0a"/>
               </a:ext>
             </a:extLst>
           </a:blip>
@@ -2915,7 +2915,7 @@
           <p:cNvPr id="6" name="light-mark-field">
             <a:extLst xmlns:a="http://schemas.openxmlformats.org/drawingml/2006/main">
               <a:ext uri="{FF2B5EF4-FFF2-40B4-BE49-F238E27FC236}">
-                <a16:creationId xmlns:a16="http://schemas.microsoft.com/office/drawing/2014/main" id="{9010C83F-ECBC-404A-9331-1E7766D02962}"/>
+                <a16:creationId xmlns:a16="http://schemas.microsoft.com/office/drawing/2014/main" id="{264A47D5-2D63-4C29-A618-6D44EF461CF8}"/>
               </a:ext>
             </a:extLst>
           </p:cNvPr>
@@ -2950,10 +2950,10 @@
           <p:nvPr/>
         </p:nvPicPr>
         <p:blipFill>
-          <a:blip xmlns:r="http://schemas.openxmlformats.org/officeDocument/2006/relationships" xmlns:a="http://schemas.openxmlformats.org/drawingml/2006/main" r:embed="R4549c26cf01246e3">
+          <a:blip xmlns:r="http://schemas.openxmlformats.org/officeDocument/2006/relationships" xmlns:a="http://schemas.openxmlformats.org/drawingml/2006/main" r:embed="R9c76ba85ae9e470a">
             <a:extLst>
               <a:ext uri="{96DAC541-7B7A-43D3-8B79-37D633B846F1}">
-                <asvg:svgBlip xmlns:asvg="http://schemas.microsoft.com/office/drawing/2016/SVG/main" r:embed="Rffe74d06a2b2456f"/>
+                <asvg:svgBlip xmlns:asvg="http://schemas.microsoft.com/office/drawing/2016/SVG/main" r:embed="R4829da0ba8234772"/>
               </a:ext>
             </a:extLst>
           </a:blip>
@@ -2974,7 +2974,7 @@
           <p:cNvPr id="8" name="light-field-label">
             <a:extLst xmlns:a="http://schemas.openxmlformats.org/drawingml/2006/main">
               <a:ext uri="{FF2B5EF4-FFF2-40B4-BE49-F238E27FC236}">
-                <a16:creationId xmlns:a16="http://schemas.microsoft.com/office/drawing/2014/main" id="{B05426C3-72EE-423E-A829-B9421D95C35E}"/>
+                <a16:creationId xmlns:a16="http://schemas.microsoft.com/office/drawing/2014/main" id="{FCEC8FEC-549A-425B-80CA-30F361EF4801}"/>
               </a:ext>
             </a:extLst>
           </p:cNvPr>
@@ -3024,7 +3024,7 @@
           <p:cNvPr id="9" name="dark-field-label">
             <a:extLst xmlns:a="http://schemas.openxmlformats.org/drawingml/2006/main">
               <a:ext uri="{FF2B5EF4-FFF2-40B4-BE49-F238E27FC236}">
-                <a16:creationId xmlns:a16="http://schemas.microsoft.com/office/drawing/2014/main" id="{E658010B-5E17-4B1C-8A72-49C6D6A3894D}"/>
+                <a16:creationId xmlns:a16="http://schemas.microsoft.com/office/drawing/2014/main" id="{B0DFC746-1942-41D8-B609-EFE6FD1CE93D}"/>
               </a:ext>
             </a:extLst>
           </p:cNvPr>
@@ -3074,7 +3074,7 @@
           <p:cNvPr id="10" name="logo-do-title">
             <a:extLst xmlns:a="http://schemas.openxmlformats.org/drawingml/2006/main">
               <a:ext uri="{FF2B5EF4-FFF2-40B4-BE49-F238E27FC236}">
-                <a16:creationId xmlns:a16="http://schemas.microsoft.com/office/drawing/2014/main" id="{8772EBC5-48F3-4491-8FBF-26384075E7ED}"/>
+                <a16:creationId xmlns:a16="http://schemas.microsoft.com/office/drawing/2014/main" id="{CFC5130F-1495-401A-AB31-B1D8F68DEE8C}"/>
               </a:ext>
             </a:extLst>
           </p:cNvPr>
@@ -3124,7 +3124,7 @@
           <p:cNvPr id="11" name="logo-do-copy">
             <a:extLst xmlns:a="http://schemas.openxmlformats.org/drawingml/2006/main">
               <a:ext uri="{FF2B5EF4-FFF2-40B4-BE49-F238E27FC236}">
-                <a16:creationId xmlns:a16="http://schemas.microsoft.com/office/drawing/2014/main" id="{5BD37CE3-FD5E-4203-A714-E6DC9ADB6C17}"/>
+                <a16:creationId xmlns:a16="http://schemas.microsoft.com/office/drawing/2014/main" id="{1E339E64-9787-4253-8997-54E56C5113D1}"/>
               </a:ext>
             </a:extLst>
           </p:cNvPr>
@@ -3174,7 +3174,7 @@
           <p:cNvPr id="12" name="logo-dont-title">
             <a:extLst xmlns:a="http://schemas.openxmlformats.org/drawingml/2006/main">
               <a:ext uri="{FF2B5EF4-FFF2-40B4-BE49-F238E27FC236}">
-                <a16:creationId xmlns:a16="http://schemas.microsoft.com/office/drawing/2014/main" id="{518A4D4A-E34E-4E5B-950B-6E34DBFD8235}"/>
+                <a16:creationId xmlns:a16="http://schemas.microsoft.com/office/drawing/2014/main" id="{9538F3CE-ED56-4807-8A30-DF8208C7D8E8}"/>
               </a:ext>
             </a:extLst>
           </p:cNvPr>
@@ -3224,7 +3224,7 @@
           <p:cNvPr id="13" name="logo-dont-copy">
             <a:extLst xmlns:a="http://schemas.openxmlformats.org/drawingml/2006/main">
               <a:ext uri="{FF2B5EF4-FFF2-40B4-BE49-F238E27FC236}">
-                <a16:creationId xmlns:a16="http://schemas.microsoft.com/office/drawing/2014/main" id="{11A44DDC-17D5-44B8-B346-8A0A4355DB59}"/>
+                <a16:creationId xmlns:a16="http://schemas.microsoft.com/office/drawing/2014/main" id="{99B1B7EB-8188-48E9-BD16-800EFDD694BE}"/>
               </a:ext>
             </a:extLst>
           </p:cNvPr>
@@ -3274,7 +3274,7 @@
           <p:cNvPr id="14" name="footer-brand">
             <a:extLst xmlns:a="http://schemas.openxmlformats.org/drawingml/2006/main">
               <a:ext uri="{FF2B5EF4-FFF2-40B4-BE49-F238E27FC236}">
-                <a16:creationId xmlns:a16="http://schemas.microsoft.com/office/drawing/2014/main" id="{E73D54C9-2B5C-4EB0-B838-076DE8583780}"/>
+                <a16:creationId xmlns:a16="http://schemas.microsoft.com/office/drawing/2014/main" id="{53127B98-264E-45F0-9261-7C6672885593}"/>
               </a:ext>
             </a:extLst>
           </p:cNvPr>
@@ -3324,7 +3324,7 @@
           <p:cNvPr id="15" name="footer-page">
             <a:extLst xmlns:a="http://schemas.openxmlformats.org/drawingml/2006/main">
               <a:ext uri="{FF2B5EF4-FFF2-40B4-BE49-F238E27FC236}">
-                <a16:creationId xmlns:a16="http://schemas.microsoft.com/office/drawing/2014/main" id="{7737B055-7BCF-4F64-8F74-B1BD5C060C32}"/>
+                <a16:creationId xmlns:a16="http://schemas.microsoft.com/office/drawing/2014/main" id="{69ECCD89-91BA-4C7C-A016-21CBE1645C38}"/>
               </a:ext>
             </a:extLst>
           </p:cNvPr>
@@ -3372,7 +3372,7 @@
     </p:spTree>
     <p:extLst>
       <p:ext uri="{BB962C8B-B14F-4D97-AF65-F5344CB8AC3E}">
-        <p14:creationId xmlns:p14="http://schemas.microsoft.com/office/powerpoint/2010/main" val="1210820110"/>
+        <p14:creationId xmlns:p14="http://schemas.microsoft.com/office/powerpoint/2010/main" val="882534774"/>
       </p:ext>
     </p:extLst>
   </p:cSld>
@@ -3403,7 +3403,7 @@
           <p:cNvPr id="34" name="eyebrow">
             <a:extLst xmlns:a="http://schemas.openxmlformats.org/drawingml/2006/main">
               <a:ext uri="{FF2B5EF4-FFF2-40B4-BE49-F238E27FC236}">
-                <a16:creationId xmlns:a16="http://schemas.microsoft.com/office/drawing/2014/main" id="{8DAC1E10-A969-49E3-920F-21B48BB23253}"/>
+                <a16:creationId xmlns:a16="http://schemas.microsoft.com/office/drawing/2014/main" id="{9A73C4B2-FEF2-4927-92C6-8E69535DA3B6}"/>
               </a:ext>
             </a:extLst>
           </p:cNvPr>
@@ -3453,7 +3453,7 @@
           <p:cNvPr id="2" name="slide-title">
             <a:extLst xmlns:a="http://schemas.openxmlformats.org/drawingml/2006/main">
               <a:ext uri="{FF2B5EF4-FFF2-40B4-BE49-F238E27FC236}">
-                <a16:creationId xmlns:a16="http://schemas.microsoft.com/office/drawing/2014/main" id="{392E0E55-BDC7-47EE-96D3-78EC2E478F0B}"/>
+                <a16:creationId xmlns:a16="http://schemas.microsoft.com/office/drawing/2014/main" id="{AB9E2E3B-4269-497D-B0E9-A5F532C44AF5}"/>
               </a:ext>
             </a:extLst>
           </p:cNvPr>
@@ -3503,7 +3503,7 @@
           <p:cNvPr id="3" name="color-1">
             <a:extLst xmlns:a="http://schemas.openxmlformats.org/drawingml/2006/main">
               <a:ext uri="{FF2B5EF4-FFF2-40B4-BE49-F238E27FC236}">
-                <a16:creationId xmlns:a16="http://schemas.microsoft.com/office/drawing/2014/main" id="{09A52E2B-23F8-46B1-AC31-39DEA3AFC629}"/>
+                <a16:creationId xmlns:a16="http://schemas.microsoft.com/office/drawing/2014/main" id="{A0535814-1973-4B0B-A744-8DA513271161}"/>
               </a:ext>
             </a:extLst>
           </p:cNvPr>
@@ -3534,7 +3534,7 @@
           <p:cNvPr id="4" name="color-name-1">
             <a:extLst xmlns:a="http://schemas.openxmlformats.org/drawingml/2006/main">
               <a:ext uri="{FF2B5EF4-FFF2-40B4-BE49-F238E27FC236}">
-                <a16:creationId xmlns:a16="http://schemas.microsoft.com/office/drawing/2014/main" id="{092F63FF-97D5-4B4B-84F8-695A06D4A1D7}"/>
+                <a16:creationId xmlns:a16="http://schemas.microsoft.com/office/drawing/2014/main" id="{8B3D4E94-2E7C-4295-98A3-278974B27958}"/>
               </a:ext>
             </a:extLst>
           </p:cNvPr>
@@ -3584,7 +3584,7 @@
           <p:cNvPr id="5" name="color-hex-1">
             <a:extLst xmlns:a="http://schemas.openxmlformats.org/drawingml/2006/main">
               <a:ext uri="{FF2B5EF4-FFF2-40B4-BE49-F238E27FC236}">
-                <a16:creationId xmlns:a16="http://schemas.microsoft.com/office/drawing/2014/main" id="{0065EC08-7D02-4FF4-B7AC-6B178CCA8851}"/>
+                <a16:creationId xmlns:a16="http://schemas.microsoft.com/office/drawing/2014/main" id="{F70A0EE7-D4FF-4CC8-8DAB-5C5592990D1E}"/>
               </a:ext>
             </a:extLst>
           </p:cNvPr>
@@ -3634,7 +3634,7 @@
           <p:cNvPr id="6" name="color-share-1">
             <a:extLst xmlns:a="http://schemas.openxmlformats.org/drawingml/2006/main">
               <a:ext uri="{FF2B5EF4-FFF2-40B4-BE49-F238E27FC236}">
-                <a16:creationId xmlns:a16="http://schemas.microsoft.com/office/drawing/2014/main" id="{93B3F9E2-301F-4AC3-BA6F-B07826AE91B7}"/>
+                <a16:creationId xmlns:a16="http://schemas.microsoft.com/office/drawing/2014/main" id="{153D77DB-BC43-4B06-9584-5D76C380E1DB}"/>
               </a:ext>
             </a:extLst>
           </p:cNvPr>
@@ -3684,7 +3684,7 @@
           <p:cNvPr id="7" name="color-2">
             <a:extLst xmlns:a="http://schemas.openxmlformats.org/drawingml/2006/main">
               <a:ext uri="{FF2B5EF4-FFF2-40B4-BE49-F238E27FC236}">
-                <a16:creationId xmlns:a16="http://schemas.microsoft.com/office/drawing/2014/main" id="{24330B6A-877C-44D3-9582-406313381D7F}"/>
+                <a16:creationId xmlns:a16="http://schemas.microsoft.com/office/drawing/2014/main" id="{9C1D502C-CEA5-426C-ABDD-F2989FF95273}"/>
               </a:ext>
             </a:extLst>
           </p:cNvPr>
@@ -3717,7 +3717,7 @@
           <p:cNvPr id="8" name="color-name-2">
             <a:extLst xmlns:a="http://schemas.openxmlformats.org/drawingml/2006/main">
               <a:ext uri="{FF2B5EF4-FFF2-40B4-BE49-F238E27FC236}">
-                <a16:creationId xmlns:a16="http://schemas.microsoft.com/office/drawing/2014/main" id="{912766C7-7720-4B33-BCB6-DA9D082F3A67}"/>
+                <a16:creationId xmlns:a16="http://schemas.microsoft.com/office/drawing/2014/main" id="{EDE5832C-636D-4AAB-80BA-768A18E7A2A7}"/>
               </a:ext>
             </a:extLst>
           </p:cNvPr>
@@ -3767,7 +3767,7 @@
           <p:cNvPr id="9" name="color-hex-2">
             <a:extLst xmlns:a="http://schemas.openxmlformats.org/drawingml/2006/main">
               <a:ext uri="{FF2B5EF4-FFF2-40B4-BE49-F238E27FC236}">
-                <a16:creationId xmlns:a16="http://schemas.microsoft.com/office/drawing/2014/main" id="{C7BA4DAE-D1E8-4E79-8B93-8A074C6CE3D0}"/>
+                <a16:creationId xmlns:a16="http://schemas.microsoft.com/office/drawing/2014/main" id="{04350D68-8955-4EA7-B71E-072FFE612C14}"/>
               </a:ext>
             </a:extLst>
           </p:cNvPr>
@@ -3817,7 +3817,7 @@
           <p:cNvPr id="10" name="color-share-2">
             <a:extLst xmlns:a="http://schemas.openxmlformats.org/drawingml/2006/main">
               <a:ext uri="{FF2B5EF4-FFF2-40B4-BE49-F238E27FC236}">
-                <a16:creationId xmlns:a16="http://schemas.microsoft.com/office/drawing/2014/main" id="{46408F43-2C71-4F78-9179-6A74D64376C1}"/>
+                <a16:creationId xmlns:a16="http://schemas.microsoft.com/office/drawing/2014/main" id="{3EA81533-4AC5-4376-A955-FB7D047964A2}"/>
               </a:ext>
             </a:extLst>
           </p:cNvPr>
@@ -3867,7 +3867,7 @@
           <p:cNvPr id="11" name="color-3">
             <a:extLst xmlns:a="http://schemas.openxmlformats.org/drawingml/2006/main">
               <a:ext uri="{FF2B5EF4-FFF2-40B4-BE49-F238E27FC236}">
-                <a16:creationId xmlns:a16="http://schemas.microsoft.com/office/drawing/2014/main" id="{3F207FA3-66FB-41AF-B06B-CFCFC6B3DE36}"/>
+                <a16:creationId xmlns:a16="http://schemas.microsoft.com/office/drawing/2014/main" id="{F8614CEE-79C8-460A-89A5-BBAF09523121}"/>
               </a:ext>
             </a:extLst>
           </p:cNvPr>
@@ -3898,7 +3898,7 @@
           <p:cNvPr id="12" name="color-name-3">
             <a:extLst xmlns:a="http://schemas.openxmlformats.org/drawingml/2006/main">
               <a:ext uri="{FF2B5EF4-FFF2-40B4-BE49-F238E27FC236}">
-                <a16:creationId xmlns:a16="http://schemas.microsoft.com/office/drawing/2014/main" id="{50B12E23-3E92-4E18-8B03-8682B67DD835}"/>
+                <a16:creationId xmlns:a16="http://schemas.microsoft.com/office/drawing/2014/main" id="{9A36CC17-98D4-448D-BBE5-CD9B4D99AE5E}"/>
               </a:ext>
             </a:extLst>
           </p:cNvPr>
@@ -3948,7 +3948,7 @@
           <p:cNvPr id="13" name="color-hex-3">
             <a:extLst xmlns:a="http://schemas.openxmlformats.org/drawingml/2006/main">
               <a:ext uri="{FF2B5EF4-FFF2-40B4-BE49-F238E27FC236}">
-                <a16:creationId xmlns:a16="http://schemas.microsoft.com/office/drawing/2014/main" id="{E761D687-2BC9-491E-8373-846E4C13F85B}"/>
+                <a16:creationId xmlns:a16="http://schemas.microsoft.com/office/drawing/2014/main" id="{2291AE33-7779-42A9-B2BF-5571D5D228F6}"/>
               </a:ext>
             </a:extLst>
           </p:cNvPr>
@@ -3998,7 +3998,7 @@
           <p:cNvPr id="14" name="color-share-3">
             <a:extLst xmlns:a="http://schemas.openxmlformats.org/drawingml/2006/main">
               <a:ext uri="{FF2B5EF4-FFF2-40B4-BE49-F238E27FC236}">
-                <a16:creationId xmlns:a16="http://schemas.microsoft.com/office/drawing/2014/main" id="{E84D59C0-A5E9-4087-A9BC-7F1F55B84929}"/>
+                <a16:creationId xmlns:a16="http://schemas.microsoft.com/office/drawing/2014/main" id="{6E9F4B3D-A957-4CE4-8D11-4DEBC1EF5704}"/>
               </a:ext>
             </a:extLst>
           </p:cNvPr>
@@ -4048,7 +4048,7 @@
           <p:cNvPr id="15" name="color-4">
             <a:extLst xmlns:a="http://schemas.openxmlformats.org/drawingml/2006/main">
               <a:ext uri="{FF2B5EF4-FFF2-40B4-BE49-F238E27FC236}">
-                <a16:creationId xmlns:a16="http://schemas.microsoft.com/office/drawing/2014/main" id="{F1CC19C2-B0CE-4DF9-B5E7-ABA71EF9305B}"/>
+                <a16:creationId xmlns:a16="http://schemas.microsoft.com/office/drawing/2014/main" id="{F5646CB2-67F7-4472-9892-B0997FA00725}"/>
               </a:ext>
             </a:extLst>
           </p:cNvPr>
@@ -4079,7 +4079,7 @@
           <p:cNvPr id="16" name="color-name-4">
             <a:extLst xmlns:a="http://schemas.openxmlformats.org/drawingml/2006/main">
               <a:ext uri="{FF2B5EF4-FFF2-40B4-BE49-F238E27FC236}">
-                <a16:creationId xmlns:a16="http://schemas.microsoft.com/office/drawing/2014/main" id="{C7EAF7DC-18D4-4B4A-A700-B2B0E62D917D}"/>
+                <a16:creationId xmlns:a16="http://schemas.microsoft.com/office/drawing/2014/main" id="{D57532EF-E8EC-4D1D-AF29-B12C02803A9E}"/>
               </a:ext>
             </a:extLst>
           </p:cNvPr>
@@ -4129,7 +4129,7 @@
           <p:cNvPr id="17" name="color-hex-4">
             <a:extLst xmlns:a="http://schemas.openxmlformats.org/drawingml/2006/main">
               <a:ext uri="{FF2B5EF4-FFF2-40B4-BE49-F238E27FC236}">
-                <a16:creationId xmlns:a16="http://schemas.microsoft.com/office/drawing/2014/main" id="{638442AA-30B1-45EE-B1E2-F2F131720FE2}"/>
+                <a16:creationId xmlns:a16="http://schemas.microsoft.com/office/drawing/2014/main" id="{7272E918-BF7C-48C6-B17A-E06743582BCC}"/>
               </a:ext>
             </a:extLst>
           </p:cNvPr>
@@ -4179,7 +4179,7 @@
           <p:cNvPr id="18" name="color-share-4">
             <a:extLst xmlns:a="http://schemas.openxmlformats.org/drawingml/2006/main">
               <a:ext uri="{FF2B5EF4-FFF2-40B4-BE49-F238E27FC236}">
-                <a16:creationId xmlns:a16="http://schemas.microsoft.com/office/drawing/2014/main" id="{210C76F6-5305-43AE-A5A6-44BCB19D722F}"/>
+                <a16:creationId xmlns:a16="http://schemas.microsoft.com/office/drawing/2014/main" id="{1D0FB535-3295-493E-B3A4-42104E94C6DD}"/>
               </a:ext>
             </a:extLst>
           </p:cNvPr>
@@ -4229,7 +4229,7 @@
           <p:cNvPr id="19" name="color-5">
             <a:extLst xmlns:a="http://schemas.openxmlformats.org/drawingml/2006/main">
               <a:ext uri="{FF2B5EF4-FFF2-40B4-BE49-F238E27FC236}">
-                <a16:creationId xmlns:a16="http://schemas.microsoft.com/office/drawing/2014/main" id="{43483F14-07DE-4373-9A55-C96FA0E3A0B5}"/>
+                <a16:creationId xmlns:a16="http://schemas.microsoft.com/office/drawing/2014/main" id="{44236F51-C22F-43B6-AD62-555BE47EE0C5}"/>
               </a:ext>
             </a:extLst>
           </p:cNvPr>
@@ -4260,7 +4260,7 @@
           <p:cNvPr id="20" name="color-name-5">
             <a:extLst xmlns:a="http://schemas.openxmlformats.org/drawingml/2006/main">
               <a:ext uri="{FF2B5EF4-FFF2-40B4-BE49-F238E27FC236}">
-                <a16:creationId xmlns:a16="http://schemas.microsoft.com/office/drawing/2014/main" id="{A8C91141-B1DB-4F08-8241-BC662A3C1753}"/>
+                <a16:creationId xmlns:a16="http://schemas.microsoft.com/office/drawing/2014/main" id="{C8B683BB-99E1-41F6-B9AD-CDD664D7F954}"/>
               </a:ext>
             </a:extLst>
           </p:cNvPr>
@@ -4310,7 +4310,7 @@
           <p:cNvPr id="21" name="color-hex-5">
             <a:extLst xmlns:a="http://schemas.openxmlformats.org/drawingml/2006/main">
               <a:ext uri="{FF2B5EF4-FFF2-40B4-BE49-F238E27FC236}">
-                <a16:creationId xmlns:a16="http://schemas.microsoft.com/office/drawing/2014/main" id="{C13CA191-2C29-4F6D-BA38-C4D524F8E035}"/>
+                <a16:creationId xmlns:a16="http://schemas.microsoft.com/office/drawing/2014/main" id="{62A76AB0-DE70-4774-801F-68902B7A910A}"/>
               </a:ext>
             </a:extLst>
           </p:cNvPr>
@@ -4360,7 +4360,7 @@
           <p:cNvPr id="22" name="color-share-5">
             <a:extLst xmlns:a="http://schemas.openxmlformats.org/drawingml/2006/main">
               <a:ext uri="{FF2B5EF4-FFF2-40B4-BE49-F238E27FC236}">
-                <a16:creationId xmlns:a16="http://schemas.microsoft.com/office/drawing/2014/main" id="{6F325E53-8F4F-4892-997C-B8D829A0D4D6}"/>
+                <a16:creationId xmlns:a16="http://schemas.microsoft.com/office/drawing/2014/main" id="{226B1DF3-41D7-4854-961E-9A4B8BF48E3D}"/>
               </a:ext>
             </a:extLst>
           </p:cNvPr>
@@ -4410,7 +4410,7 @@
           <p:cNvPr id="23" name="color-6">
             <a:extLst xmlns:a="http://schemas.openxmlformats.org/drawingml/2006/main">
               <a:ext uri="{FF2B5EF4-FFF2-40B4-BE49-F238E27FC236}">
-                <a16:creationId xmlns:a16="http://schemas.microsoft.com/office/drawing/2014/main" id="{80925D60-2670-4E8C-8F07-DF9DC2AFA96B}"/>
+                <a16:creationId xmlns:a16="http://schemas.microsoft.com/office/drawing/2014/main" id="{C001E575-FB8F-4571-8A9C-4CD5A3DE7E46}"/>
               </a:ext>
             </a:extLst>
           </p:cNvPr>
@@ -4441,7 +4441,7 @@
           <p:cNvPr id="24" name="color-name-6">
             <a:extLst xmlns:a="http://schemas.openxmlformats.org/drawingml/2006/main">
               <a:ext uri="{FF2B5EF4-FFF2-40B4-BE49-F238E27FC236}">
-                <a16:creationId xmlns:a16="http://schemas.microsoft.com/office/drawing/2014/main" id="{7978D55B-1142-4656-8E4A-F2CF325F9846}"/>
+                <a16:creationId xmlns:a16="http://schemas.microsoft.com/office/drawing/2014/main" id="{1BE9718D-87F5-4903-83CC-DF4BC4CC6694}"/>
               </a:ext>
             </a:extLst>
           </p:cNvPr>
@@ -4491,7 +4491,7 @@
           <p:cNvPr id="25" name="color-hex-6">
             <a:extLst xmlns:a="http://schemas.openxmlformats.org/drawingml/2006/main">
               <a:ext uri="{FF2B5EF4-FFF2-40B4-BE49-F238E27FC236}">
-                <a16:creationId xmlns:a16="http://schemas.microsoft.com/office/drawing/2014/main" id="{73FB37D2-6811-4A37-94D2-CAA2BE775DE9}"/>
+                <a16:creationId xmlns:a16="http://schemas.microsoft.com/office/drawing/2014/main" id="{A3718892-74EF-473E-BFA8-BA7012BA9FF1}"/>
               </a:ext>
             </a:extLst>
           </p:cNvPr>
@@ -4541,7 +4541,7 @@
           <p:cNvPr id="26" name="color-share-6">
             <a:extLst xmlns:a="http://schemas.openxmlformats.org/drawingml/2006/main">
               <a:ext uri="{FF2B5EF4-FFF2-40B4-BE49-F238E27FC236}">
-                <a16:creationId xmlns:a16="http://schemas.microsoft.com/office/drawing/2014/main" id="{1A8597A0-C071-4F05-B61E-318C99989A9B}"/>
+                <a16:creationId xmlns:a16="http://schemas.microsoft.com/office/drawing/2014/main" id="{3B028A0C-1F06-47E9-94C8-A4CCC0C3B387}"/>
               </a:ext>
             </a:extLst>
           </p:cNvPr>
@@ -4591,7 +4591,7 @@
           <p:cNvPr id="27" name="color-7">
             <a:extLst xmlns:a="http://schemas.openxmlformats.org/drawingml/2006/main">
               <a:ext uri="{FF2B5EF4-FFF2-40B4-BE49-F238E27FC236}">
-                <a16:creationId xmlns:a16="http://schemas.microsoft.com/office/drawing/2014/main" id="{3FA306D0-57C6-4552-B94B-CF224EF33514}"/>
+                <a16:creationId xmlns:a16="http://schemas.microsoft.com/office/drawing/2014/main" id="{AA4D7D79-0FE1-459A-9A98-A58359959C06}"/>
               </a:ext>
             </a:extLst>
           </p:cNvPr>
@@ -4622,7 +4622,7 @@
           <p:cNvPr id="28" name="color-name-7">
             <a:extLst xmlns:a="http://schemas.openxmlformats.org/drawingml/2006/main">
               <a:ext uri="{FF2B5EF4-FFF2-40B4-BE49-F238E27FC236}">
-                <a16:creationId xmlns:a16="http://schemas.microsoft.com/office/drawing/2014/main" id="{110BC648-AEAA-4FD8-8A2E-52C2C13E552C}"/>
+                <a16:creationId xmlns:a16="http://schemas.microsoft.com/office/drawing/2014/main" id="{E861E25D-ED45-4437-A8B8-8F0EE40C06F0}"/>
               </a:ext>
             </a:extLst>
           </p:cNvPr>
@@ -4672,7 +4672,7 @@
           <p:cNvPr id="29" name="color-hex-7">
             <a:extLst xmlns:a="http://schemas.openxmlformats.org/drawingml/2006/main">
               <a:ext uri="{FF2B5EF4-FFF2-40B4-BE49-F238E27FC236}">
-                <a16:creationId xmlns:a16="http://schemas.microsoft.com/office/drawing/2014/main" id="{D031E2A3-57E1-4FE3-B7CD-31C7D2F304D3}"/>
+                <a16:creationId xmlns:a16="http://schemas.microsoft.com/office/drawing/2014/main" id="{6DCA49C2-4E00-4582-BA5F-88C41C345A81}"/>
               </a:ext>
             </a:extLst>
           </p:cNvPr>
@@ -4722,7 +4722,7 @@
           <p:cNvPr id="30" name="color-share-7">
             <a:extLst xmlns:a="http://schemas.openxmlformats.org/drawingml/2006/main">
               <a:ext uri="{FF2B5EF4-FFF2-40B4-BE49-F238E27FC236}">
-                <a16:creationId xmlns:a16="http://schemas.microsoft.com/office/drawing/2014/main" id="{5AE90951-D150-42B6-AEED-40B583A6A6E1}"/>
+                <a16:creationId xmlns:a16="http://schemas.microsoft.com/office/drawing/2014/main" id="{1CD82992-2D4E-48E0-951E-486F13F7EBF4}"/>
               </a:ext>
             </a:extLst>
           </p:cNvPr>
@@ -4772,7 +4772,7 @@
           <p:cNvPr id="31" name="color-guidance">
             <a:extLst xmlns:a="http://schemas.openxmlformats.org/drawingml/2006/main">
               <a:ext uri="{FF2B5EF4-FFF2-40B4-BE49-F238E27FC236}">
-                <a16:creationId xmlns:a16="http://schemas.microsoft.com/office/drawing/2014/main" id="{035A855B-874B-48B6-984F-20FB0B0144C5}"/>
+                <a16:creationId xmlns:a16="http://schemas.microsoft.com/office/drawing/2014/main" id="{A42A996F-3149-4F0D-A150-10EDCB97775D}"/>
               </a:ext>
             </a:extLst>
           </p:cNvPr>
@@ -4822,7 +4822,7 @@
           <p:cNvPr id="32" name="footer-brand">
             <a:extLst xmlns:a="http://schemas.openxmlformats.org/drawingml/2006/main">
               <a:ext uri="{FF2B5EF4-FFF2-40B4-BE49-F238E27FC236}">
-                <a16:creationId xmlns:a16="http://schemas.microsoft.com/office/drawing/2014/main" id="{52D46A9F-3FDC-4962-9A6D-F93974ED1B50}"/>
+                <a16:creationId xmlns:a16="http://schemas.microsoft.com/office/drawing/2014/main" id="{A64F7D22-814A-419F-9740-AD0C1347CFDE}"/>
               </a:ext>
             </a:extLst>
           </p:cNvPr>
@@ -4872,7 +4872,7 @@
           <p:cNvPr id="33" name="footer-page">
             <a:extLst xmlns:a="http://schemas.openxmlformats.org/drawingml/2006/main">
               <a:ext uri="{FF2B5EF4-FFF2-40B4-BE49-F238E27FC236}">
-                <a16:creationId xmlns:a16="http://schemas.microsoft.com/office/drawing/2014/main" id="{463FE127-35CF-43AB-A6C0-CA06E4BD7BA1}"/>
+                <a16:creationId xmlns:a16="http://schemas.microsoft.com/office/drawing/2014/main" id="{44FBF076-AB4A-456E-85A0-FBF72D09C387}"/>
               </a:ext>
             </a:extLst>
           </p:cNvPr>
@@ -4920,7 +4920,7 @@
     </p:spTree>
     <p:extLst>
       <p:ext uri="{BB962C8B-B14F-4D97-AF65-F5344CB8AC3E}">
-        <p14:creationId xmlns:p14="http://schemas.microsoft.com/office/powerpoint/2010/main" val="1990203222"/>
+        <p14:creationId xmlns:p14="http://schemas.microsoft.com/office/powerpoint/2010/main" val="270636784"/>
       </p:ext>
     </p:extLst>
   </p:cSld>
@@ -4951,7 +4951,7 @@
           <p:cNvPr id="17" name="eyebrow">
             <a:extLst xmlns:a="http://schemas.openxmlformats.org/drawingml/2006/main">
               <a:ext uri="{FF2B5EF4-FFF2-40B4-BE49-F238E27FC236}">
-                <a16:creationId xmlns:a16="http://schemas.microsoft.com/office/drawing/2014/main" id="{F953DE7E-C901-4043-984F-DD497F483807}"/>
+                <a16:creationId xmlns:a16="http://schemas.microsoft.com/office/drawing/2014/main" id="{D225A44B-9998-4F42-A7AF-0E5D15ED7AA2}"/>
               </a:ext>
             </a:extLst>
           </p:cNvPr>
@@ -5001,7 +5001,7 @@
           <p:cNvPr id="2" name="slide-title">
             <a:extLst xmlns:a="http://schemas.openxmlformats.org/drawingml/2006/main">
               <a:ext uri="{FF2B5EF4-FFF2-40B4-BE49-F238E27FC236}">
-                <a16:creationId xmlns:a16="http://schemas.microsoft.com/office/drawing/2014/main" id="{9F1624AA-2177-4072-AEDC-35F7A9AEEB06}"/>
+                <a16:creationId xmlns:a16="http://schemas.microsoft.com/office/drawing/2014/main" id="{5E5D5DCB-32AE-49EF-9055-71B2F536AD62}"/>
               </a:ext>
             </a:extLst>
           </p:cNvPr>
@@ -5051,7 +5051,7 @@
           <p:cNvPr id="3" name="display-specimen">
             <a:extLst xmlns:a="http://schemas.openxmlformats.org/drawingml/2006/main">
               <a:ext uri="{FF2B5EF4-FFF2-40B4-BE49-F238E27FC236}">
-                <a16:creationId xmlns:a16="http://schemas.microsoft.com/office/drawing/2014/main" id="{B775F138-DC6B-4535-853C-2E0B9F7574E2}"/>
+                <a16:creationId xmlns:a16="http://schemas.microsoft.com/office/drawing/2014/main" id="{2B218CF9-A597-49D0-A994-3B103E23A2A4}"/>
               </a:ext>
             </a:extLst>
           </p:cNvPr>
@@ -5101,7 +5101,7 @@
           <p:cNvPr id="4" name="display-type-cover">
             <a:extLst xmlns:a="http://schemas.openxmlformats.org/drawingml/2006/main">
               <a:ext uri="{FF2B5EF4-FFF2-40B4-BE49-F238E27FC236}">
-                <a16:creationId xmlns:a16="http://schemas.microsoft.com/office/drawing/2014/main" id="{BB496D3B-64B6-4A7B-8332-2A561D0CA63B}"/>
+                <a16:creationId xmlns:a16="http://schemas.microsoft.com/office/drawing/2014/main" id="{3C62F901-AB58-4D6C-A7D2-ED4ED7671B62}"/>
               </a:ext>
             </a:extLst>
           </p:cNvPr>
@@ -5136,10 +5136,10 @@
           <p:nvPr/>
         </p:nvPicPr>
         <p:blipFill>
-          <a:blip xmlns:r="http://schemas.openxmlformats.org/officeDocument/2006/relationships" xmlns:a="http://schemas.openxmlformats.org/drawingml/2006/main" r:embed="Rb531d9e51b5d44fe">
+          <a:blip xmlns:r="http://schemas.openxmlformats.org/officeDocument/2006/relationships" xmlns:a="http://schemas.openxmlformats.org/drawingml/2006/main" r:embed="Rdf3ac47cc0824701">
             <a:extLst>
               <a:ext uri="{96DAC541-7B7A-43D3-8B79-37D633B846F1}">
-                <asvg:svgBlip xmlns:asvg="http://schemas.microsoft.com/office/drawing/2016/SVG/main" r:embed="R4bd7852bdfa64de6"/>
+                <asvg:svgBlip xmlns:asvg="http://schemas.microsoft.com/office/drawing/2016/SVG/main" r:embed="Rb0c480e8c6de4f51"/>
               </a:ext>
             </a:extLst>
           </a:blip>
@@ -5160,7 +5160,7 @@
           <p:cNvPr id="6" name="display-label">
             <a:extLst xmlns:a="http://schemas.openxmlformats.org/drawingml/2006/main">
               <a:ext uri="{FF2B5EF4-FFF2-40B4-BE49-F238E27FC236}">
-                <a16:creationId xmlns:a16="http://schemas.microsoft.com/office/drawing/2014/main" id="{6E235EA6-9774-4617-B7EE-FF0F3B04ABD1}"/>
+                <a16:creationId xmlns:a16="http://schemas.microsoft.com/office/drawing/2014/main" id="{C4573DD9-2268-4C0C-9C18-1B14D99F051C}"/>
               </a:ext>
             </a:extLst>
           </p:cNvPr>
@@ -5210,7 +5210,7 @@
           <p:cNvPr id="7" name="tagline-specimen">
             <a:extLst xmlns:a="http://schemas.openxmlformats.org/drawingml/2006/main">
               <a:ext uri="{FF2B5EF4-FFF2-40B4-BE49-F238E27FC236}">
-                <a16:creationId xmlns:a16="http://schemas.microsoft.com/office/drawing/2014/main" id="{47EAA694-BF7C-43C6-8653-8B04612A01EE}"/>
+                <a16:creationId xmlns:a16="http://schemas.microsoft.com/office/drawing/2014/main" id="{0AE84A7A-5C65-4C05-876F-28211AE847D6}"/>
               </a:ext>
             </a:extLst>
           </p:cNvPr>
@@ -5260,7 +5260,7 @@
           <p:cNvPr id="8" name="tagline-label">
             <a:extLst xmlns:a="http://schemas.openxmlformats.org/drawingml/2006/main">
               <a:ext uri="{FF2B5EF4-FFF2-40B4-BE49-F238E27FC236}">
-                <a16:creationId xmlns:a16="http://schemas.microsoft.com/office/drawing/2014/main" id="{0DE12216-CD35-4FFB-BFC8-EE7514E49C73}"/>
+                <a16:creationId xmlns:a16="http://schemas.microsoft.com/office/drawing/2014/main" id="{A6AB071F-04C3-459B-9000-0B73777E674C}"/>
               </a:ext>
             </a:extLst>
           </p:cNvPr>
@@ -5310,7 +5310,7 @@
           <p:cNvPr id="9" name="body-type-field">
             <a:extLst xmlns:a="http://schemas.openxmlformats.org/drawingml/2006/main">
               <a:ext uri="{FF2B5EF4-FFF2-40B4-BE49-F238E27FC236}">
-                <a16:creationId xmlns:a16="http://schemas.microsoft.com/office/drawing/2014/main" id="{4DB88C82-22D3-4A3E-A90E-B7EFA299C635}"/>
+                <a16:creationId xmlns:a16="http://schemas.microsoft.com/office/drawing/2014/main" id="{DE85E183-20C7-46DF-8FB5-B9DB629F168B}"/>
               </a:ext>
             </a:extLst>
           </p:cNvPr>
@@ -5341,7 +5341,7 @@
           <p:cNvPr id="10" name="body-title">
             <a:extLst xmlns:a="http://schemas.openxmlformats.org/drawingml/2006/main">
               <a:ext uri="{FF2B5EF4-FFF2-40B4-BE49-F238E27FC236}">
-                <a16:creationId xmlns:a16="http://schemas.microsoft.com/office/drawing/2014/main" id="{472DD75F-9B61-4D4F-A89A-87F832C7BE1A}"/>
+                <a16:creationId xmlns:a16="http://schemas.microsoft.com/office/drawing/2014/main" id="{ECE97695-AD0E-485C-BB93-2FED9BBFB39D}"/>
               </a:ext>
             </a:extLst>
           </p:cNvPr>
@@ -5391,7 +5391,7 @@
           <p:cNvPr id="11" name="body-specimen">
             <a:extLst xmlns:a="http://schemas.openxmlformats.org/drawingml/2006/main">
               <a:ext uri="{FF2B5EF4-FFF2-40B4-BE49-F238E27FC236}">
-                <a16:creationId xmlns:a16="http://schemas.microsoft.com/office/drawing/2014/main" id="{B715EC64-64BB-4EA3-964C-A698AF22B290}"/>
+                <a16:creationId xmlns:a16="http://schemas.microsoft.com/office/drawing/2014/main" id="{D920790B-E447-47A6-B325-6DE8DDF075D1}"/>
               </a:ext>
             </a:extLst>
           </p:cNvPr>
@@ -5441,7 +5441,7 @@
           <p:cNvPr id="12" name="mono-title">
             <a:extLst xmlns:a="http://schemas.openxmlformats.org/drawingml/2006/main">
               <a:ext uri="{FF2B5EF4-FFF2-40B4-BE49-F238E27FC236}">
-                <a16:creationId xmlns:a16="http://schemas.microsoft.com/office/drawing/2014/main" id="{126E0465-E975-4537-8426-3609D0AAF8AC}"/>
+                <a16:creationId xmlns:a16="http://schemas.microsoft.com/office/drawing/2014/main" id="{9B1F6C57-5CA3-4502-A2A8-38DCA9A31BDD}"/>
               </a:ext>
             </a:extLst>
           </p:cNvPr>
@@ -5491,7 +5491,7 @@
           <p:cNvPr id="13" name="mono-specimen">
             <a:extLst xmlns:a="http://schemas.openxmlformats.org/drawingml/2006/main">
               <a:ext uri="{FF2B5EF4-FFF2-40B4-BE49-F238E27FC236}">
-                <a16:creationId xmlns:a16="http://schemas.microsoft.com/office/drawing/2014/main" id="{594A9C5D-FED7-4CB5-B7E3-63A348AA825A}"/>
+                <a16:creationId xmlns:a16="http://schemas.microsoft.com/office/drawing/2014/main" id="{6C66F76D-AF95-4420-B006-562D4E301333}"/>
               </a:ext>
             </a:extLst>
           </p:cNvPr>
@@ -5541,7 +5541,7 @@
           <p:cNvPr id="14" name="mono-copy">
             <a:extLst xmlns:a="http://schemas.openxmlformats.org/drawingml/2006/main">
               <a:ext uri="{FF2B5EF4-FFF2-40B4-BE49-F238E27FC236}">
-                <a16:creationId xmlns:a16="http://schemas.microsoft.com/office/drawing/2014/main" id="{33B5D419-4374-4FC7-BF18-3E8F46347530}"/>
+                <a16:creationId xmlns:a16="http://schemas.microsoft.com/office/drawing/2014/main" id="{AE2168CC-D16F-4E8B-A1FD-34299AFDED4E}"/>
               </a:ext>
             </a:extLst>
           </p:cNvPr>
@@ -5591,7 +5591,7 @@
           <p:cNvPr id="15" name="footer-brand">
             <a:extLst xmlns:a="http://schemas.openxmlformats.org/drawingml/2006/main">
               <a:ext uri="{FF2B5EF4-FFF2-40B4-BE49-F238E27FC236}">
-                <a16:creationId xmlns:a16="http://schemas.microsoft.com/office/drawing/2014/main" id="{D010E114-C1BF-4B4B-AD6A-B9D1262E9ECA}"/>
+                <a16:creationId xmlns:a16="http://schemas.microsoft.com/office/drawing/2014/main" id="{A904F6A4-CA2A-45FD-B061-F9DF83CBC811}"/>
               </a:ext>
             </a:extLst>
           </p:cNvPr>
@@ -5641,7 +5641,7 @@
           <p:cNvPr id="16" name="footer-page">
             <a:extLst xmlns:a="http://schemas.openxmlformats.org/drawingml/2006/main">
               <a:ext uri="{FF2B5EF4-FFF2-40B4-BE49-F238E27FC236}">
-                <a16:creationId xmlns:a16="http://schemas.microsoft.com/office/drawing/2014/main" id="{C9768762-E741-47BE-8B6A-5485F32FF089}"/>
+                <a16:creationId xmlns:a16="http://schemas.microsoft.com/office/drawing/2014/main" id="{8DDD0D5E-27A5-44B6-AD67-A93D4F3EACC2}"/>
               </a:ext>
             </a:extLst>
           </p:cNvPr>
@@ -5689,7 +5689,7 @@
     </p:spTree>
     <p:extLst>
       <p:ext uri="{BB962C8B-B14F-4D97-AF65-F5344CB8AC3E}">
-        <p14:creationId xmlns:p14="http://schemas.microsoft.com/office/powerpoint/2010/main" val="2054158472"/>
+        <p14:creationId xmlns:p14="http://schemas.microsoft.com/office/powerpoint/2010/main" val="597990413"/>
       </p:ext>
     </p:extLst>
   </p:cSld>
@@ -5720,7 +5720,7 @@
           <p:cNvPr id="16" name="eyebrow">
             <a:extLst xmlns:a="http://schemas.openxmlformats.org/drawingml/2006/main">
               <a:ext uri="{FF2B5EF4-FFF2-40B4-BE49-F238E27FC236}">
-                <a16:creationId xmlns:a16="http://schemas.microsoft.com/office/drawing/2014/main" id="{3DE1F7F5-BEEA-4A73-B2E6-64475AB4E4D9}"/>
+                <a16:creationId xmlns:a16="http://schemas.microsoft.com/office/drawing/2014/main" id="{4178E321-45AA-44A6-845B-A80240A2FFB1}"/>
               </a:ext>
             </a:extLst>
           </p:cNvPr>
@@ -5770,7 +5770,7 @@
           <p:cNvPr id="2" name="slide-title">
             <a:extLst xmlns:a="http://schemas.openxmlformats.org/drawingml/2006/main">
               <a:ext uri="{FF2B5EF4-FFF2-40B4-BE49-F238E27FC236}">
-                <a16:creationId xmlns:a16="http://schemas.microsoft.com/office/drawing/2014/main" id="{F248B35E-5AA0-4420-93C9-96B8047238F8}"/>
+                <a16:creationId xmlns:a16="http://schemas.microsoft.com/office/drawing/2014/main" id="{47C8A6FC-4741-43E8-824A-76A507CF2434}"/>
               </a:ext>
             </a:extLst>
           </p:cNvPr>
@@ -5824,7 +5824,7 @@
           <p:nvPr/>
         </p:nvPicPr>
         <p:blipFill>
-          <a:blip xmlns:r="http://schemas.openxmlformats.org/officeDocument/2006/relationships" xmlns:a="http://schemas.openxmlformats.org/drawingml/2006/main" r:embed="R2bbb5eecf6094b82"/>
+          <a:blip xmlns:r="http://schemas.openxmlformats.org/officeDocument/2006/relationships" xmlns:a="http://schemas.openxmlformats.org/drawingml/2006/main" r:embed="Rb618a5ac120f4e82"/>
           <a:stretch xmlns:a="http://schemas.openxmlformats.org/drawingml/2006/main"/>
         </p:blipFill>
         <p:spPr>
@@ -5846,10 +5846,10 @@
           <p:nvPr/>
         </p:nvPicPr>
         <p:blipFill>
-          <a:blip xmlns:r="http://schemas.openxmlformats.org/officeDocument/2006/relationships" xmlns:a="http://schemas.openxmlformats.org/drawingml/2006/main" r:embed="R49ab05ea074b48b8">
+          <a:blip xmlns:r="http://schemas.openxmlformats.org/officeDocument/2006/relationships" xmlns:a="http://schemas.openxmlformats.org/drawingml/2006/main" r:embed="R2806deec64484a0e">
             <a:extLst>
               <a:ext uri="{96DAC541-7B7A-43D3-8B79-37D633B846F1}">
-                <asvg:svgBlip xmlns:asvg="http://schemas.microsoft.com/office/drawing/2016/SVG/main" r:embed="Ra9bf1ea9e9704fae"/>
+                <asvg:svgBlip xmlns:asvg="http://schemas.microsoft.com/office/drawing/2016/SVG/main" r:embed="R5fe20c61a8a54576"/>
               </a:ext>
             </a:extLst>
           </a:blip>
@@ -5870,7 +5870,7 @@
           <p:cNvPr id="5" name="illustration-rule-1">
             <a:extLst xmlns:a="http://schemas.openxmlformats.org/drawingml/2006/main">
               <a:ext uri="{FF2B5EF4-FFF2-40B4-BE49-F238E27FC236}">
-                <a16:creationId xmlns:a16="http://schemas.microsoft.com/office/drawing/2014/main" id="{76269AEE-FF2B-496E-8A8E-DC07006EDAC0}"/>
+                <a16:creationId xmlns:a16="http://schemas.microsoft.com/office/drawing/2014/main" id="{62E06637-F1A8-4673-AFC2-A8F695B1D2C0}"/>
               </a:ext>
             </a:extLst>
           </p:cNvPr>
@@ -5901,7 +5901,7 @@
           <p:cNvPr id="6" name="illustration-title-1">
             <a:extLst xmlns:a="http://schemas.openxmlformats.org/drawingml/2006/main">
               <a:ext uri="{FF2B5EF4-FFF2-40B4-BE49-F238E27FC236}">
-                <a16:creationId xmlns:a16="http://schemas.microsoft.com/office/drawing/2014/main" id="{72589332-C659-4761-9633-00D4A468D4CD}"/>
+                <a16:creationId xmlns:a16="http://schemas.microsoft.com/office/drawing/2014/main" id="{E35AED30-8D62-4B7C-AEB9-E5EF5EB6F53F}"/>
               </a:ext>
             </a:extLst>
           </p:cNvPr>
@@ -5951,7 +5951,7 @@
           <p:cNvPr id="7" name="illustration-copy-1">
             <a:extLst xmlns:a="http://schemas.openxmlformats.org/drawingml/2006/main">
               <a:ext uri="{FF2B5EF4-FFF2-40B4-BE49-F238E27FC236}">
-                <a16:creationId xmlns:a16="http://schemas.microsoft.com/office/drawing/2014/main" id="{50D2DBF2-E7D5-4F9E-9F1C-555E75FDE57F}"/>
+                <a16:creationId xmlns:a16="http://schemas.microsoft.com/office/drawing/2014/main" id="{A46F44E9-3192-4EC4-A03D-FC4490C10D60}"/>
               </a:ext>
             </a:extLst>
           </p:cNvPr>
@@ -6001,7 +6001,7 @@
           <p:cNvPr id="8" name="illustration-rule-2">
             <a:extLst xmlns:a="http://schemas.openxmlformats.org/drawingml/2006/main">
               <a:ext uri="{FF2B5EF4-FFF2-40B4-BE49-F238E27FC236}">
-                <a16:creationId xmlns:a16="http://schemas.microsoft.com/office/drawing/2014/main" id="{E0CD210E-B27A-45E8-8E6B-B3B808FDCC77}"/>
+                <a16:creationId xmlns:a16="http://schemas.microsoft.com/office/drawing/2014/main" id="{03F2E21E-0587-4D10-AB6A-B2EEFB8751B1}"/>
               </a:ext>
             </a:extLst>
           </p:cNvPr>
@@ -6032,7 +6032,7 @@
           <p:cNvPr id="9" name="illustration-title-2">
             <a:extLst xmlns:a="http://schemas.openxmlformats.org/drawingml/2006/main">
               <a:ext uri="{FF2B5EF4-FFF2-40B4-BE49-F238E27FC236}">
-                <a16:creationId xmlns:a16="http://schemas.microsoft.com/office/drawing/2014/main" id="{431EB85C-88E9-4ABD-B50D-32C85E24C9B3}"/>
+                <a16:creationId xmlns:a16="http://schemas.microsoft.com/office/drawing/2014/main" id="{67622F5D-B074-43A1-BF39-CB6748303ADF}"/>
               </a:ext>
             </a:extLst>
           </p:cNvPr>
@@ -6082,7 +6082,7 @@
           <p:cNvPr id="10" name="illustration-copy-2">
             <a:extLst xmlns:a="http://schemas.openxmlformats.org/drawingml/2006/main">
               <a:ext uri="{FF2B5EF4-FFF2-40B4-BE49-F238E27FC236}">
-                <a16:creationId xmlns:a16="http://schemas.microsoft.com/office/drawing/2014/main" id="{4FF66470-200F-4187-B0A3-30C636586DA1}"/>
+                <a16:creationId xmlns:a16="http://schemas.microsoft.com/office/drawing/2014/main" id="{E26E1609-7041-4E31-A5A2-FDE1A7F2B562}"/>
               </a:ext>
             </a:extLst>
           </p:cNvPr>
@@ -6132,7 +6132,7 @@
           <p:cNvPr id="11" name="illustration-rule-3">
             <a:extLst xmlns:a="http://schemas.openxmlformats.org/drawingml/2006/main">
               <a:ext uri="{FF2B5EF4-FFF2-40B4-BE49-F238E27FC236}">
-                <a16:creationId xmlns:a16="http://schemas.microsoft.com/office/drawing/2014/main" id="{CD38A167-F6E5-4797-B428-3AD649000CCD}"/>
+                <a16:creationId xmlns:a16="http://schemas.microsoft.com/office/drawing/2014/main" id="{0CFD23F8-BEFA-4E00-82A8-FA4CC2D3D296}"/>
               </a:ext>
             </a:extLst>
           </p:cNvPr>
@@ -6163,7 +6163,7 @@
           <p:cNvPr id="12" name="illustration-title-3">
             <a:extLst xmlns:a="http://schemas.openxmlformats.org/drawingml/2006/main">
               <a:ext uri="{FF2B5EF4-FFF2-40B4-BE49-F238E27FC236}">
-                <a16:creationId xmlns:a16="http://schemas.microsoft.com/office/drawing/2014/main" id="{D3624BF7-E076-4D33-AEF9-4A32CFD0A118}"/>
+                <a16:creationId xmlns:a16="http://schemas.microsoft.com/office/drawing/2014/main" id="{E27270B1-8663-4CF8-85FD-4505C6F1F723}"/>
               </a:ext>
             </a:extLst>
           </p:cNvPr>
@@ -6213,7 +6213,7 @@
           <p:cNvPr id="13" name="illustration-copy-3">
             <a:extLst xmlns:a="http://schemas.openxmlformats.org/drawingml/2006/main">
               <a:ext uri="{FF2B5EF4-FFF2-40B4-BE49-F238E27FC236}">
-                <a16:creationId xmlns:a16="http://schemas.microsoft.com/office/drawing/2014/main" id="{E7858EC8-EEB8-4AA0-9525-CDD87AEDC5E0}"/>
+                <a16:creationId xmlns:a16="http://schemas.microsoft.com/office/drawing/2014/main" id="{C55AA42F-AF93-442E-87A4-A5E3CDC92F2F}"/>
               </a:ext>
             </a:extLst>
           </p:cNvPr>
@@ -6263,7 +6263,7 @@
           <p:cNvPr id="14" name="footer-brand">
             <a:extLst xmlns:a="http://schemas.openxmlformats.org/drawingml/2006/main">
               <a:ext uri="{FF2B5EF4-FFF2-40B4-BE49-F238E27FC236}">
-                <a16:creationId xmlns:a16="http://schemas.microsoft.com/office/drawing/2014/main" id="{B2454A6B-3D3A-44EF-B0FC-2A526A727DAF}"/>
+                <a16:creationId xmlns:a16="http://schemas.microsoft.com/office/drawing/2014/main" id="{B7959751-1D96-4EB6-94F8-C90F66151E73}"/>
               </a:ext>
             </a:extLst>
           </p:cNvPr>
@@ -6313,7 +6313,7 @@
           <p:cNvPr id="15" name="footer-page">
             <a:extLst xmlns:a="http://schemas.openxmlformats.org/drawingml/2006/main">
               <a:ext uri="{FF2B5EF4-FFF2-40B4-BE49-F238E27FC236}">
-                <a16:creationId xmlns:a16="http://schemas.microsoft.com/office/drawing/2014/main" id="{45451E17-9D35-4F75-BCB9-D4AC665F6578}"/>
+                <a16:creationId xmlns:a16="http://schemas.microsoft.com/office/drawing/2014/main" id="{D8130BC0-AABA-4287-92D3-E7AF6D7E846A}"/>
               </a:ext>
             </a:extLst>
           </p:cNvPr>
@@ -6361,7 +6361,7 @@
     </p:spTree>
     <p:extLst>
       <p:ext uri="{BB962C8B-B14F-4D97-AF65-F5344CB8AC3E}">
-        <p14:creationId xmlns:p14="http://schemas.microsoft.com/office/powerpoint/2010/main" val="1924789756"/>
+        <p14:creationId xmlns:p14="http://schemas.microsoft.com/office/powerpoint/2010/main" val="991589392"/>
       </p:ext>
     </p:extLst>
   </p:cSld>
@@ -6392,7 +6392,7 @@
           <p:cNvPr id="22" name="eyebrow">
             <a:extLst xmlns:a="http://schemas.openxmlformats.org/drawingml/2006/main">
               <a:ext uri="{FF2B5EF4-FFF2-40B4-BE49-F238E27FC236}">
-                <a16:creationId xmlns:a16="http://schemas.microsoft.com/office/drawing/2014/main" id="{AD426B3B-1D1A-4692-9806-B1FCBC765EB8}"/>
+                <a16:creationId xmlns:a16="http://schemas.microsoft.com/office/drawing/2014/main" id="{C162AD51-252E-4737-A178-42280CE93AF2}"/>
               </a:ext>
             </a:extLst>
           </p:cNvPr>
@@ -6442,7 +6442,7 @@
           <p:cNvPr id="2" name="slide-title">
             <a:extLst xmlns:a="http://schemas.openxmlformats.org/drawingml/2006/main">
               <a:ext uri="{FF2B5EF4-FFF2-40B4-BE49-F238E27FC236}">
-                <a16:creationId xmlns:a16="http://schemas.microsoft.com/office/drawing/2014/main" id="{09A778D9-8AF1-4227-8357-8C933D4239A0}"/>
+                <a16:creationId xmlns:a16="http://schemas.microsoft.com/office/drawing/2014/main" id="{F1040006-0E51-47F7-AA59-24931613F598}"/>
               </a:ext>
             </a:extLst>
           </p:cNvPr>
@@ -6496,7 +6496,7 @@
           <p:nvPr/>
         </p:nvPicPr>
         <p:blipFill>
-          <a:blip xmlns:r="http://schemas.openxmlformats.org/officeDocument/2006/relationships" xmlns:a="http://schemas.openxmlformats.org/drawingml/2006/main" r:embed="R7d2e5f048a984bda"/>
+          <a:blip xmlns:r="http://schemas.openxmlformats.org/officeDocument/2006/relationships" xmlns:a="http://schemas.openxmlformats.org/drawingml/2006/main" r:embed="Rdcd95050b62843fb"/>
           <a:stretch xmlns:a="http://schemas.openxmlformats.org/drawingml/2006/main"/>
         </p:blipFill>
         <p:spPr>
@@ -6518,7 +6518,7 @@
           <p:nvPr/>
         </p:nvPicPr>
         <p:blipFill>
-          <a:blip xmlns:r="http://schemas.openxmlformats.org/officeDocument/2006/relationships" xmlns:a="http://schemas.openxmlformats.org/drawingml/2006/main" r:embed="Rce449201e3314f63"/>
+          <a:blip xmlns:r="http://schemas.openxmlformats.org/officeDocument/2006/relationships" xmlns:a="http://schemas.openxmlformats.org/drawingml/2006/main" r:embed="R09af77c5dad54f68"/>
           <a:stretch xmlns:a="http://schemas.openxmlformats.org/drawingml/2006/main"/>
         </p:blipFill>
         <p:spPr>
@@ -6536,7 +6536,7 @@
           <p:cNvPr id="5" name="establish-label">
             <a:extLst xmlns:a="http://schemas.openxmlformats.org/drawingml/2006/main">
               <a:ext uri="{FF2B5EF4-FFF2-40B4-BE49-F238E27FC236}">
-                <a16:creationId xmlns:a16="http://schemas.microsoft.com/office/drawing/2014/main" id="{0573D7FB-E71F-41FA-9F9A-F54D27FF42E6}"/>
+                <a16:creationId xmlns:a16="http://schemas.microsoft.com/office/drawing/2014/main" id="{CE7389B0-1C5F-4EA1-BA6C-9973C2FB1243}"/>
               </a:ext>
             </a:extLst>
           </p:cNvPr>
@@ -6586,7 +6586,7 @@
           <p:cNvPr id="6" name="detail-label">
             <a:extLst xmlns:a="http://schemas.openxmlformats.org/drawingml/2006/main">
               <a:ext uri="{FF2B5EF4-FFF2-40B4-BE49-F238E27FC236}">
-                <a16:creationId xmlns:a16="http://schemas.microsoft.com/office/drawing/2014/main" id="{2F7B784A-743C-4BA0-85EC-FF7B2B38D05A}"/>
+                <a16:creationId xmlns:a16="http://schemas.microsoft.com/office/drawing/2014/main" id="{C50788B7-6A03-428E-978D-4494C6C1A5C9}"/>
               </a:ext>
             </a:extLst>
           </p:cNvPr>
@@ -6636,7 +6636,7 @@
           <p:cNvPr id="7" name="motion-stage-1">
             <a:extLst xmlns:a="http://schemas.openxmlformats.org/drawingml/2006/main">
               <a:ext uri="{FF2B5EF4-FFF2-40B4-BE49-F238E27FC236}">
-                <a16:creationId xmlns:a16="http://schemas.microsoft.com/office/drawing/2014/main" id="{BDCBFA23-A38A-40E1-9A58-B4DA0D8DE0A7}"/>
+                <a16:creationId xmlns:a16="http://schemas.microsoft.com/office/drawing/2014/main" id="{4FCBBDB9-20DE-4CE2-8629-07C20BC8D82A}"/>
               </a:ext>
             </a:extLst>
           </p:cNvPr>
@@ -6667,7 +6667,7 @@
           <p:cNvPr id="8" name="motion-title-1">
             <a:extLst xmlns:a="http://schemas.openxmlformats.org/drawingml/2006/main">
               <a:ext uri="{FF2B5EF4-FFF2-40B4-BE49-F238E27FC236}">
-                <a16:creationId xmlns:a16="http://schemas.microsoft.com/office/drawing/2014/main" id="{75F4F0F3-9154-4689-9EB9-B26E254EB2AA}"/>
+                <a16:creationId xmlns:a16="http://schemas.microsoft.com/office/drawing/2014/main" id="{BD99D35B-F18B-4BAC-9653-5A108EAD834C}"/>
               </a:ext>
             </a:extLst>
           </p:cNvPr>
@@ -6717,7 +6717,7 @@
           <p:cNvPr id="9" name="motion-copy-1">
             <a:extLst xmlns:a="http://schemas.openxmlformats.org/drawingml/2006/main">
               <a:ext uri="{FF2B5EF4-FFF2-40B4-BE49-F238E27FC236}">
-                <a16:creationId xmlns:a16="http://schemas.microsoft.com/office/drawing/2014/main" id="{22301161-864B-44D3-B4F7-1714EF5BD8F8}"/>
+                <a16:creationId xmlns:a16="http://schemas.microsoft.com/office/drawing/2014/main" id="{A4A00F1C-23B3-4DC1-8CD6-B5F005498F20}"/>
               </a:ext>
             </a:extLst>
           </p:cNvPr>
@@ -6767,7 +6767,7 @@
           <p:cNvPr id="10" name="motion-stage-2">
             <a:extLst xmlns:a="http://schemas.openxmlformats.org/drawingml/2006/main">
               <a:ext uri="{FF2B5EF4-FFF2-40B4-BE49-F238E27FC236}">
-                <a16:creationId xmlns:a16="http://schemas.microsoft.com/office/drawing/2014/main" id="{ED9B2F2A-8810-4229-BE0E-26DE43686739}"/>
+                <a16:creationId xmlns:a16="http://schemas.microsoft.com/office/drawing/2014/main" id="{61D80DF1-E7E1-4036-B0BC-7C219098E58F}"/>
               </a:ext>
             </a:extLst>
           </p:cNvPr>
@@ -6798,7 +6798,7 @@
           <p:cNvPr id="11" name="motion-title-2">
             <a:extLst xmlns:a="http://schemas.openxmlformats.org/drawingml/2006/main">
               <a:ext uri="{FF2B5EF4-FFF2-40B4-BE49-F238E27FC236}">
-                <a16:creationId xmlns:a16="http://schemas.microsoft.com/office/drawing/2014/main" id="{5BC096B2-86BA-4FBA-A194-35E744D977FA}"/>
+                <a16:creationId xmlns:a16="http://schemas.microsoft.com/office/drawing/2014/main" id="{B040486C-6C8A-4866-86E5-B409F7870C3F}"/>
               </a:ext>
             </a:extLst>
           </p:cNvPr>
@@ -6848,7 +6848,7 @@
           <p:cNvPr id="12" name="motion-copy-2">
             <a:extLst xmlns:a="http://schemas.openxmlformats.org/drawingml/2006/main">
               <a:ext uri="{FF2B5EF4-FFF2-40B4-BE49-F238E27FC236}">
-                <a16:creationId xmlns:a16="http://schemas.microsoft.com/office/drawing/2014/main" id="{B3D81322-FDF3-45ED-88D1-CCC1BF3C4B87}"/>
+                <a16:creationId xmlns:a16="http://schemas.microsoft.com/office/drawing/2014/main" id="{4C4D6BC8-6ADB-4382-959F-0C7BA4873426}"/>
               </a:ext>
             </a:extLst>
           </p:cNvPr>
@@ -6898,7 +6898,7 @@
           <p:cNvPr id="13" name="motion-stage-3">
             <a:extLst xmlns:a="http://schemas.openxmlformats.org/drawingml/2006/main">
               <a:ext uri="{FF2B5EF4-FFF2-40B4-BE49-F238E27FC236}">
-                <a16:creationId xmlns:a16="http://schemas.microsoft.com/office/drawing/2014/main" id="{BF1A91B9-CF28-454E-9DCA-2C75F5FE23E9}"/>
+                <a16:creationId xmlns:a16="http://schemas.microsoft.com/office/drawing/2014/main" id="{B198A85A-3B2E-46AB-A712-EBDD12F950A5}"/>
               </a:ext>
             </a:extLst>
           </p:cNvPr>
@@ -6929,7 +6929,7 @@
           <p:cNvPr id="14" name="motion-title-3">
             <a:extLst xmlns:a="http://schemas.openxmlformats.org/drawingml/2006/main">
               <a:ext uri="{FF2B5EF4-FFF2-40B4-BE49-F238E27FC236}">
-                <a16:creationId xmlns:a16="http://schemas.microsoft.com/office/drawing/2014/main" id="{6CC71656-D9FC-4DDE-B1C0-26548D4E1044}"/>
+                <a16:creationId xmlns:a16="http://schemas.microsoft.com/office/drawing/2014/main" id="{70B10112-86D8-4F65-9FBC-8B4FF0E9C25B}"/>
               </a:ext>
             </a:extLst>
           </p:cNvPr>
@@ -6979,7 +6979,7 @@
           <p:cNvPr id="15" name="motion-copy-3">
             <a:extLst xmlns:a="http://schemas.openxmlformats.org/drawingml/2006/main">
               <a:ext uri="{FF2B5EF4-FFF2-40B4-BE49-F238E27FC236}">
-                <a16:creationId xmlns:a16="http://schemas.microsoft.com/office/drawing/2014/main" id="{F6FF71AC-872C-4452-B058-D8180C663A60}"/>
+                <a16:creationId xmlns:a16="http://schemas.microsoft.com/office/drawing/2014/main" id="{6E7A66E8-0C57-4A8B-8BFD-E29221CD0993}"/>
               </a:ext>
             </a:extLst>
           </p:cNvPr>
@@ -7029,7 +7029,7 @@
           <p:cNvPr id="16" name="motion-stage-4">
             <a:extLst xmlns:a="http://schemas.openxmlformats.org/drawingml/2006/main">
               <a:ext uri="{FF2B5EF4-FFF2-40B4-BE49-F238E27FC236}">
-                <a16:creationId xmlns:a16="http://schemas.microsoft.com/office/drawing/2014/main" id="{FC3B1753-19B1-499B-80B3-AEB93DE69737}"/>
+                <a16:creationId xmlns:a16="http://schemas.microsoft.com/office/drawing/2014/main" id="{19139771-3A62-485A-A8D5-CCDC451914F3}"/>
               </a:ext>
             </a:extLst>
           </p:cNvPr>
@@ -7060,7 +7060,7 @@
           <p:cNvPr id="17" name="motion-title-4">
             <a:extLst xmlns:a="http://schemas.openxmlformats.org/drawingml/2006/main">
               <a:ext uri="{FF2B5EF4-FFF2-40B4-BE49-F238E27FC236}">
-                <a16:creationId xmlns:a16="http://schemas.microsoft.com/office/drawing/2014/main" id="{FD6D5304-3136-41CF-835C-07C4CF483BF4}"/>
+                <a16:creationId xmlns:a16="http://schemas.microsoft.com/office/drawing/2014/main" id="{2378F3AF-C1CC-4288-A2D2-E470F29A8580}"/>
               </a:ext>
             </a:extLst>
           </p:cNvPr>
@@ -7110,7 +7110,7 @@
           <p:cNvPr id="18" name="motion-copy-4">
             <a:extLst xmlns:a="http://schemas.openxmlformats.org/drawingml/2006/main">
               <a:ext uri="{FF2B5EF4-FFF2-40B4-BE49-F238E27FC236}">
-                <a16:creationId xmlns:a16="http://schemas.microsoft.com/office/drawing/2014/main" id="{6BA76BFF-DFB9-4EA6-85A2-AF42AC995064}"/>
+                <a16:creationId xmlns:a16="http://schemas.microsoft.com/office/drawing/2014/main" id="{D5221A72-E76C-493D-98BF-607263A2E974}"/>
               </a:ext>
             </a:extLst>
           </p:cNvPr>
@@ -7160,7 +7160,7 @@
           <p:cNvPr id="19" name="motion-surface-rule">
             <a:extLst xmlns:a="http://schemas.openxmlformats.org/drawingml/2006/main">
               <a:ext uri="{FF2B5EF4-FFF2-40B4-BE49-F238E27FC236}">
-                <a16:creationId xmlns:a16="http://schemas.microsoft.com/office/drawing/2014/main" id="{9ACBACF4-159F-4BCE-9285-2293F4E8277D}"/>
+                <a16:creationId xmlns:a16="http://schemas.microsoft.com/office/drawing/2014/main" id="{6FA0E000-F6D2-47FE-9198-97E5C5EE3F93}"/>
               </a:ext>
             </a:extLst>
           </p:cNvPr>
@@ -7210,7 +7210,7 @@
           <p:cNvPr id="20" name="footer-brand">
             <a:extLst xmlns:a="http://schemas.openxmlformats.org/drawingml/2006/main">
               <a:ext uri="{FF2B5EF4-FFF2-40B4-BE49-F238E27FC236}">
-                <a16:creationId xmlns:a16="http://schemas.microsoft.com/office/drawing/2014/main" id="{F2408A01-A7B9-495D-AB91-BBB3153E5B6F}"/>
+                <a16:creationId xmlns:a16="http://schemas.microsoft.com/office/drawing/2014/main" id="{EEA2F53C-ABFA-492A-BCEB-D81176A4C337}"/>
               </a:ext>
             </a:extLst>
           </p:cNvPr>
@@ -7260,7 +7260,7 @@
           <p:cNvPr id="21" name="footer-page">
             <a:extLst xmlns:a="http://schemas.openxmlformats.org/drawingml/2006/main">
               <a:ext uri="{FF2B5EF4-FFF2-40B4-BE49-F238E27FC236}">
-                <a16:creationId xmlns:a16="http://schemas.microsoft.com/office/drawing/2014/main" id="{64EF4818-50BB-4ACD-8949-53ABF5DD9078}"/>
+                <a16:creationId xmlns:a16="http://schemas.microsoft.com/office/drawing/2014/main" id="{E46B06E0-232B-4A9E-8389-156B11F7DE1A}"/>
               </a:ext>
             </a:extLst>
           </p:cNvPr>
@@ -7308,7 +7308,7 @@
     </p:spTree>
     <p:extLst>
       <p:ext uri="{BB962C8B-B14F-4D97-AF65-F5344CB8AC3E}">
-        <p14:creationId xmlns:p14="http://schemas.microsoft.com/office/powerpoint/2010/main" val="1861590475"/>
+        <p14:creationId xmlns:p14="http://schemas.microsoft.com/office/powerpoint/2010/main" val="1385869203"/>
       </p:ext>
     </p:extLst>
   </p:cSld>
@@ -7339,7 +7339,7 @@
           <p:cNvPr id="11" name="eyebrow">
             <a:extLst xmlns:a="http://schemas.openxmlformats.org/drawingml/2006/main">
               <a:ext uri="{FF2B5EF4-FFF2-40B4-BE49-F238E27FC236}">
-                <a16:creationId xmlns:a16="http://schemas.microsoft.com/office/drawing/2014/main" id="{9E942033-9FDC-49AF-A88F-D298BE624205}"/>
+                <a16:creationId xmlns:a16="http://schemas.microsoft.com/office/drawing/2014/main" id="{D2C6BB83-3981-4205-A104-CA01A6476647}"/>
               </a:ext>
             </a:extLst>
           </p:cNvPr>
@@ -7389,7 +7389,7 @@
           <p:cNvPr id="2" name="slide-title">
             <a:extLst xmlns:a="http://schemas.openxmlformats.org/drawingml/2006/main">
               <a:ext uri="{FF2B5EF4-FFF2-40B4-BE49-F238E27FC236}">
-                <a16:creationId xmlns:a16="http://schemas.microsoft.com/office/drawing/2014/main" id="{6B75D2C9-D594-4456-9C7D-DC4672D78F78}"/>
+                <a16:creationId xmlns:a16="http://schemas.microsoft.com/office/drawing/2014/main" id="{4A28FAC9-6FA9-41B4-B756-2324E41EE238}"/>
               </a:ext>
             </a:extLst>
           </p:cNvPr>
@@ -7439,7 +7439,7 @@
           <p:cNvPr id="3" name="github-surface">
             <a:extLst xmlns:a="http://schemas.openxmlformats.org/drawingml/2006/main">
               <a:ext uri="{FF2B5EF4-FFF2-40B4-BE49-F238E27FC236}">
-                <a16:creationId xmlns:a16="http://schemas.microsoft.com/office/drawing/2014/main" id="{62C96455-0028-4ADA-9B6A-D6512CEDFA60}"/>
+                <a16:creationId xmlns:a16="http://schemas.microsoft.com/office/drawing/2014/main" id="{EA07951F-0D23-42E8-A4CE-26E1904E4522}"/>
               </a:ext>
             </a:extLst>
           </p:cNvPr>
@@ -7470,7 +7470,7 @@
           <p:cNvPr id="4" name="github-label">
             <a:extLst xmlns:a="http://schemas.openxmlformats.org/drawingml/2006/main">
               <a:ext uri="{FF2B5EF4-FFF2-40B4-BE49-F238E27FC236}">
-                <a16:creationId xmlns:a16="http://schemas.microsoft.com/office/drawing/2014/main" id="{9A874637-7088-419F-8E3A-74FB8332797B}"/>
+                <a16:creationId xmlns:a16="http://schemas.microsoft.com/office/drawing/2014/main" id="{A3B4350A-DD68-4197-9618-942297134255}"/>
               </a:ext>
             </a:extLst>
           </p:cNvPr>
@@ -7524,7 +7524,7 @@
           <p:nvPr/>
         </p:nvPicPr>
         <p:blipFill>
-          <a:blip xmlns:r="http://schemas.openxmlformats.org/officeDocument/2006/relationships" xmlns:a="http://schemas.openxmlformats.org/drawingml/2006/main" r:embed="R9f873c620c944614"/>
+          <a:blip xmlns:r="http://schemas.openxmlformats.org/officeDocument/2006/relationships" xmlns:a="http://schemas.openxmlformats.org/drawingml/2006/main" r:embed="Rc5e7d3a51f824ec3"/>
           <a:stretch xmlns:a="http://schemas.openxmlformats.org/drawingml/2006/main"/>
         </p:blipFill>
         <p:spPr>
@@ -7546,10 +7546,10 @@
           <p:nvPr/>
         </p:nvPicPr>
         <p:blipFill>
-          <a:blip xmlns:r="http://schemas.openxmlformats.org/officeDocument/2006/relationships" xmlns:a="http://schemas.openxmlformats.org/drawingml/2006/main" r:embed="Ra23ca14cdda545cc">
+          <a:blip xmlns:r="http://schemas.openxmlformats.org/officeDocument/2006/relationships" xmlns:a="http://schemas.openxmlformats.org/drawingml/2006/main" r:embed="R3c66e2d283154c27">
             <a:extLst>
               <a:ext uri="{96DAC541-7B7A-43D3-8B79-37D633B846F1}">
-                <asvg:svgBlip xmlns:asvg="http://schemas.microsoft.com/office/drawing/2016/SVG/main" r:embed="R4021cc8d5e8a4a55"/>
+                <asvg:svgBlip xmlns:asvg="http://schemas.microsoft.com/office/drawing/2016/SVG/main" r:embed="R7ee7952cb678492a"/>
               </a:ext>
             </a:extLst>
           </a:blip>
@@ -7570,7 +7570,7 @@
           <p:cNvPr id="7" name="github-size">
             <a:extLst xmlns:a="http://schemas.openxmlformats.org/drawingml/2006/main">
               <a:ext uri="{FF2B5EF4-FFF2-40B4-BE49-F238E27FC236}">
-                <a16:creationId xmlns:a16="http://schemas.microsoft.com/office/drawing/2014/main" id="{8C1CAEBD-58DE-401A-926E-95CEE3C77E17}"/>
+                <a16:creationId xmlns:a16="http://schemas.microsoft.com/office/drawing/2014/main" id="{59DA0546-7741-4208-88C9-7D1F19B6AD3F}"/>
               </a:ext>
             </a:extLst>
           </p:cNvPr>
@@ -7620,7 +7620,7 @@
           <p:cNvPr id="8" name="github-guidance">
             <a:extLst xmlns:a="http://schemas.openxmlformats.org/drawingml/2006/main">
               <a:ext uri="{FF2B5EF4-FFF2-40B4-BE49-F238E27FC236}">
-                <a16:creationId xmlns:a16="http://schemas.microsoft.com/office/drawing/2014/main" id="{F1AB8BF2-8C97-4C48-A3B8-7B9EDB1786AE}"/>
+                <a16:creationId xmlns:a16="http://schemas.microsoft.com/office/drawing/2014/main" id="{A543BC4F-1AA2-426D-9CEA-5A97E5D5939F}"/>
               </a:ext>
             </a:extLst>
           </p:cNvPr>
@@ -7670,7 +7670,7 @@
           <p:cNvPr id="9" name="footer-brand">
             <a:extLst xmlns:a="http://schemas.openxmlformats.org/drawingml/2006/main">
               <a:ext uri="{FF2B5EF4-FFF2-40B4-BE49-F238E27FC236}">
-                <a16:creationId xmlns:a16="http://schemas.microsoft.com/office/drawing/2014/main" id="{AE7E8271-D0AB-4F47-9311-8114124634D3}"/>
+                <a16:creationId xmlns:a16="http://schemas.microsoft.com/office/drawing/2014/main" id="{C0ECC30C-A117-4EA1-93DA-CA43933F5A0C}"/>
               </a:ext>
             </a:extLst>
           </p:cNvPr>
@@ -7720,7 +7720,7 @@
           <p:cNvPr id="10" name="footer-page">
             <a:extLst xmlns:a="http://schemas.openxmlformats.org/drawingml/2006/main">
               <a:ext uri="{FF2B5EF4-FFF2-40B4-BE49-F238E27FC236}">
-                <a16:creationId xmlns:a16="http://schemas.microsoft.com/office/drawing/2014/main" id="{4BF91D40-05A7-4501-8EF6-20C37EC8F3BF}"/>
+                <a16:creationId xmlns:a16="http://schemas.microsoft.com/office/drawing/2014/main" id="{74D5DC49-97B7-4FF9-914B-798C25E9853E}"/>
               </a:ext>
             </a:extLst>
           </p:cNvPr>
@@ -7768,7 +7768,7 @@
     </p:spTree>
     <p:extLst>
       <p:ext uri="{BB962C8B-B14F-4D97-AF65-F5344CB8AC3E}">
-        <p14:creationId xmlns:p14="http://schemas.microsoft.com/office/powerpoint/2010/main" val="677887592"/>
+        <p14:creationId xmlns:p14="http://schemas.microsoft.com/office/powerpoint/2010/main" val="1940947507"/>
       </p:ext>
     </p:extLst>
   </p:cSld>
@@ -7799,7 +7799,7 @@
           <p:cNvPr id="19" name="eyebrow">
             <a:extLst xmlns:a="http://schemas.openxmlformats.org/drawingml/2006/main">
               <a:ext uri="{FF2B5EF4-FFF2-40B4-BE49-F238E27FC236}">
-                <a16:creationId xmlns:a16="http://schemas.microsoft.com/office/drawing/2014/main" id="{C7005271-1F8D-45E4-9318-7F736EB0B6A6}"/>
+                <a16:creationId xmlns:a16="http://schemas.microsoft.com/office/drawing/2014/main" id="{D9CD79CA-5122-470D-8B3A-9182EFA57F53}"/>
               </a:ext>
             </a:extLst>
           </p:cNvPr>
@@ -7853,10 +7853,10 @@
           <p:nvPr/>
         </p:nvPicPr>
         <p:blipFill>
-          <a:blip xmlns:r="http://schemas.openxmlformats.org/officeDocument/2006/relationships" xmlns:a="http://schemas.openxmlformats.org/drawingml/2006/main" r:embed="R8d3a4dd78e92497d">
+          <a:blip xmlns:r="http://schemas.openxmlformats.org/officeDocument/2006/relationships" xmlns:a="http://schemas.openxmlformats.org/drawingml/2006/main" r:embed="Re5ea0339b840432b">
             <a:extLst>
               <a:ext uri="{96DAC541-7B7A-43D3-8B79-37D633B846F1}">
-                <asvg:svgBlip xmlns:asvg="http://schemas.microsoft.com/office/drawing/2016/SVG/main" r:embed="R9ccf24c70aeb409b"/>
+                <asvg:svgBlip xmlns:asvg="http://schemas.microsoft.com/office/drawing/2016/SVG/main" r:embed="Ra0e0ec489bff47ac"/>
               </a:ext>
             </a:extLst>
           </a:blip>
@@ -7877,7 +7877,7 @@
           <p:cNvPr id="3" name="closing-title">
             <a:extLst xmlns:a="http://schemas.openxmlformats.org/drawingml/2006/main">
               <a:ext uri="{FF2B5EF4-FFF2-40B4-BE49-F238E27FC236}">
-                <a16:creationId xmlns:a16="http://schemas.microsoft.com/office/drawing/2014/main" id="{D9964EE4-D670-4B28-A2DD-566622449E2C}"/>
+                <a16:creationId xmlns:a16="http://schemas.microsoft.com/office/drawing/2014/main" id="{89C7FF79-B2A5-4F2C-BE0B-6947EB7393A1}"/>
               </a:ext>
             </a:extLst>
           </p:cNvPr>
@@ -7927,7 +7927,7 @@
           <p:cNvPr id="4" name="closing-copy">
             <a:extLst xmlns:a="http://schemas.openxmlformats.org/drawingml/2006/main">
               <a:ext uri="{FF2B5EF4-FFF2-40B4-BE49-F238E27FC236}">
-                <a16:creationId xmlns:a16="http://schemas.microsoft.com/office/drawing/2014/main" id="{42623A70-97C2-4A71-8789-ADCCB644432E}"/>
+                <a16:creationId xmlns:a16="http://schemas.microsoft.com/office/drawing/2014/main" id="{5F632FC0-D3C9-437A-9D06-D3A0B8C78CD6}"/>
               </a:ext>
             </a:extLst>
           </p:cNvPr>
@@ -7977,7 +7977,7 @@
           <p:cNvPr id="5" name="release-check-1">
             <a:extLst xmlns:a="http://schemas.openxmlformats.org/drawingml/2006/main">
               <a:ext uri="{FF2B5EF4-FFF2-40B4-BE49-F238E27FC236}">
-                <a16:creationId xmlns:a16="http://schemas.microsoft.com/office/drawing/2014/main" id="{5657FC70-7DD2-4BA6-B916-765ABE961AAB}"/>
+                <a16:creationId xmlns:a16="http://schemas.microsoft.com/office/drawing/2014/main" id="{2E1A2DE2-4995-4169-AD5D-A935A84E2278}"/>
               </a:ext>
             </a:extLst>
           </p:cNvPr>
@@ -8008,7 +8008,7 @@
           <p:cNvPr id="6" name="release-title-1">
             <a:extLst xmlns:a="http://schemas.openxmlformats.org/drawingml/2006/main">
               <a:ext uri="{FF2B5EF4-FFF2-40B4-BE49-F238E27FC236}">
-                <a16:creationId xmlns:a16="http://schemas.microsoft.com/office/drawing/2014/main" id="{AE9E202B-692F-4D6A-9389-9AD57BA3205E}"/>
+                <a16:creationId xmlns:a16="http://schemas.microsoft.com/office/drawing/2014/main" id="{02486FDA-C6D0-4285-9024-E1F785A3D398}"/>
               </a:ext>
             </a:extLst>
           </p:cNvPr>
@@ -8058,7 +8058,7 @@
           <p:cNvPr id="7" name="release-copy-1">
             <a:extLst xmlns:a="http://schemas.openxmlformats.org/drawingml/2006/main">
               <a:ext uri="{FF2B5EF4-FFF2-40B4-BE49-F238E27FC236}">
-                <a16:creationId xmlns:a16="http://schemas.microsoft.com/office/drawing/2014/main" id="{C4CCB85B-50CA-4497-84A4-4A5B48367A29}"/>
+                <a16:creationId xmlns:a16="http://schemas.microsoft.com/office/drawing/2014/main" id="{BEF0B8C6-1F40-43F2-996E-596D2E1D1479}"/>
               </a:ext>
             </a:extLst>
           </p:cNvPr>
@@ -8108,7 +8108,7 @@
           <p:cNvPr id="8" name="release-check-2">
             <a:extLst xmlns:a="http://schemas.openxmlformats.org/drawingml/2006/main">
               <a:ext uri="{FF2B5EF4-FFF2-40B4-BE49-F238E27FC236}">
-                <a16:creationId xmlns:a16="http://schemas.microsoft.com/office/drawing/2014/main" id="{41CF84F8-3758-4CFF-99DB-B8E5BBE37B63}"/>
+                <a16:creationId xmlns:a16="http://schemas.microsoft.com/office/drawing/2014/main" id="{283BB601-40A3-439F-998F-9624DAFB879B}"/>
               </a:ext>
             </a:extLst>
           </p:cNvPr>
@@ -8139,7 +8139,7 @@
           <p:cNvPr id="9" name="release-title-2">
             <a:extLst xmlns:a="http://schemas.openxmlformats.org/drawingml/2006/main">
               <a:ext uri="{FF2B5EF4-FFF2-40B4-BE49-F238E27FC236}">
-                <a16:creationId xmlns:a16="http://schemas.microsoft.com/office/drawing/2014/main" id="{8BE45CC8-AACD-48EA-82C8-3AC33AE0DFD3}"/>
+                <a16:creationId xmlns:a16="http://schemas.microsoft.com/office/drawing/2014/main" id="{AD5E575B-019F-4AAA-B4B0-C2B156B154D4}"/>
               </a:ext>
             </a:extLst>
           </p:cNvPr>
@@ -8189,7 +8189,7 @@
           <p:cNvPr id="10" name="release-copy-2">
             <a:extLst xmlns:a="http://schemas.openxmlformats.org/drawingml/2006/main">
               <a:ext uri="{FF2B5EF4-FFF2-40B4-BE49-F238E27FC236}">
-                <a16:creationId xmlns:a16="http://schemas.microsoft.com/office/drawing/2014/main" id="{EFE9A59B-97E7-42C5-8C95-2434DF011732}"/>
+                <a16:creationId xmlns:a16="http://schemas.microsoft.com/office/drawing/2014/main" id="{44FA0225-3C9D-43E6-9D11-132A208ACD85}"/>
               </a:ext>
             </a:extLst>
           </p:cNvPr>
@@ -8239,7 +8239,7 @@
           <p:cNvPr id="11" name="release-check-3">
             <a:extLst xmlns:a="http://schemas.openxmlformats.org/drawingml/2006/main">
               <a:ext uri="{FF2B5EF4-FFF2-40B4-BE49-F238E27FC236}">
-                <a16:creationId xmlns:a16="http://schemas.microsoft.com/office/drawing/2014/main" id="{8BB9BD21-EF93-4262-AFF0-53712FB68355}"/>
+                <a16:creationId xmlns:a16="http://schemas.microsoft.com/office/drawing/2014/main" id="{C0CAA368-1ACA-413A-B215-04EE45BDFCF6}"/>
               </a:ext>
             </a:extLst>
           </p:cNvPr>
@@ -8270,7 +8270,7 @@
           <p:cNvPr id="12" name="release-title-3">
             <a:extLst xmlns:a="http://schemas.openxmlformats.org/drawingml/2006/main">
               <a:ext uri="{FF2B5EF4-FFF2-40B4-BE49-F238E27FC236}">
-                <a16:creationId xmlns:a16="http://schemas.microsoft.com/office/drawing/2014/main" id="{03DACE8E-F9C4-4CFE-B60D-8316B93CEB37}"/>
+                <a16:creationId xmlns:a16="http://schemas.microsoft.com/office/drawing/2014/main" id="{7F7D78A7-CAF6-413A-A1E0-505D7DB88744}"/>
               </a:ext>
             </a:extLst>
           </p:cNvPr>
@@ -8320,7 +8320,7 @@
           <p:cNvPr id="13" name="release-copy-3">
             <a:extLst xmlns:a="http://schemas.openxmlformats.org/drawingml/2006/main">
               <a:ext uri="{FF2B5EF4-FFF2-40B4-BE49-F238E27FC236}">
-                <a16:creationId xmlns:a16="http://schemas.microsoft.com/office/drawing/2014/main" id="{2FF49342-40EE-4BB6-A2BE-A889D6023EE9}"/>
+                <a16:creationId xmlns:a16="http://schemas.microsoft.com/office/drawing/2014/main" id="{5BF6980A-E274-4D2A-BB27-54CB0F2B3265}"/>
               </a:ext>
             </a:extLst>
           </p:cNvPr>
@@ -8370,7 +8370,7 @@
           <p:cNvPr id="14" name="release-check-4">
             <a:extLst xmlns:a="http://schemas.openxmlformats.org/drawingml/2006/main">
               <a:ext uri="{FF2B5EF4-FFF2-40B4-BE49-F238E27FC236}">
-                <a16:creationId xmlns:a16="http://schemas.microsoft.com/office/drawing/2014/main" id="{076A7C47-1DF5-4D32-A821-9DC32C0541F7}"/>
+                <a16:creationId xmlns:a16="http://schemas.microsoft.com/office/drawing/2014/main" id="{30E69197-89AC-470D-9AE7-A54225BF82BC}"/>
               </a:ext>
             </a:extLst>
           </p:cNvPr>
@@ -8401,7 +8401,7 @@
           <p:cNvPr id="15" name="release-title-4">
             <a:extLst xmlns:a="http://schemas.openxmlformats.org/drawingml/2006/main">
               <a:ext uri="{FF2B5EF4-FFF2-40B4-BE49-F238E27FC236}">
-                <a16:creationId xmlns:a16="http://schemas.microsoft.com/office/drawing/2014/main" id="{B7F6D95B-68BC-4CAE-839E-33826FD8815D}"/>
+                <a16:creationId xmlns:a16="http://schemas.microsoft.com/office/drawing/2014/main" id="{027F74D3-62E4-445D-8626-0BD6621391A4}"/>
               </a:ext>
             </a:extLst>
           </p:cNvPr>
@@ -8451,7 +8451,7 @@
           <p:cNvPr id="16" name="release-copy-4">
             <a:extLst xmlns:a="http://schemas.openxmlformats.org/drawingml/2006/main">
               <a:ext uri="{FF2B5EF4-FFF2-40B4-BE49-F238E27FC236}">
-                <a16:creationId xmlns:a16="http://schemas.microsoft.com/office/drawing/2014/main" id="{A9496B5E-7AB5-4E22-92DB-6146D18F790C}"/>
+                <a16:creationId xmlns:a16="http://schemas.microsoft.com/office/drawing/2014/main" id="{45492FCA-AFB9-478C-A9B5-27E2E60AEECC}"/>
               </a:ext>
             </a:extLst>
           </p:cNvPr>
@@ -8501,7 +8501,7 @@
           <p:cNvPr id="17" name="footer-brand">
             <a:extLst xmlns:a="http://schemas.openxmlformats.org/drawingml/2006/main">
               <a:ext uri="{FF2B5EF4-FFF2-40B4-BE49-F238E27FC236}">
-                <a16:creationId xmlns:a16="http://schemas.microsoft.com/office/drawing/2014/main" id="{0AE2BC4B-1F35-49B1-BA98-A4FEA7CBBC1E}"/>
+                <a16:creationId xmlns:a16="http://schemas.microsoft.com/office/drawing/2014/main" id="{F993396F-6F04-498E-AE75-9CD996C9D738}"/>
               </a:ext>
             </a:extLst>
           </p:cNvPr>
@@ -8551,7 +8551,7 @@
           <p:cNvPr id="18" name="footer-page">
             <a:extLst xmlns:a="http://schemas.openxmlformats.org/drawingml/2006/main">
               <a:ext uri="{FF2B5EF4-FFF2-40B4-BE49-F238E27FC236}">
-                <a16:creationId xmlns:a16="http://schemas.microsoft.com/office/drawing/2014/main" id="{497A46CD-A73E-4D71-AF00-756BEF778C9F}"/>
+                <a16:creationId xmlns:a16="http://schemas.microsoft.com/office/drawing/2014/main" id="{1CB8801E-EBD0-48E9-846A-1D049182E8A0}"/>
               </a:ext>
             </a:extLst>
           </p:cNvPr>
@@ -8599,7 +8599,7 @@
     </p:spTree>
     <p:extLst>
       <p:ext uri="{BB962C8B-B14F-4D97-AF65-F5344CB8AC3E}">
-        <p14:creationId xmlns:p14="http://schemas.microsoft.com/office/powerpoint/2010/main" val="1735295555"/>
+        <p14:creationId xmlns:p14="http://schemas.microsoft.com/office/powerpoint/2010/main" val="1917034917"/>
       </p:ext>
     </p:extLst>
   </p:cSld>

</xml_diff>